<commit_message>
style(presentation): apply official Ashesi University brand guidelines (Pale Carmine, Garamond, logo badge)
</commit_message>
<xml_diff>
--- a/reports/ITN_Allocation_Presentation.pptx
+++ b/reports/ITN_Allocation_Presentation.pptx
@@ -3114,7 +3114,7 @@
             <a:avLst/>
           </a:prstGeom>
           <a:solidFill>
-            <a:srgbClr val="0F2043"/>
+            <a:srgbClr val="5E1214"/>
           </a:solidFill>
           <a:ln>
             <a:noFill/>
@@ -3144,14 +3144,57 @@
       </p:sp>
       <p:sp>
         <p:nvSpPr>
-          <p:cNvPr id="3" name="TextBox 2"/>
+          <p:cNvPr id="3" name="Rectangle 2"/>
+          <p:cNvSpPr/>
+          <p:nvPr/>
+        </p:nvSpPr>
+        <p:spPr>
+          <a:xfrm>
+            <a:off x="914400" y="1371600"/>
+            <a:ext cx="73152" cy="4114800"/>
+          </a:xfrm>
+          <a:prstGeom prst="rect">
+            <a:avLst/>
+          </a:prstGeom>
+          <a:solidFill>
+            <a:srgbClr val="C59B27"/>
+          </a:solidFill>
+          <a:ln>
+            <a:noFill/>
+          </a:ln>
+        </p:spPr>
+        <p:style>
+          <a:lnRef idx="1">
+            <a:schemeClr val="accent1"/>
+          </a:lnRef>
+          <a:fillRef idx="3">
+            <a:schemeClr val="accent1"/>
+          </a:fillRef>
+          <a:effectRef idx="2">
+            <a:schemeClr val="accent1"/>
+          </a:effectRef>
+          <a:fontRef idx="minor">
+            <a:schemeClr val="lt1"/>
+          </a:fontRef>
+        </p:style>
+        <p:txBody>
+          <a:bodyPr rtlCol="0" anchor="ctr"/>
+          <a:lstStyle/>
+          <a:p>
+            <a:pPr algn="ctr"/>
+          </a:p>
+        </p:txBody>
+      </p:sp>
+      <p:sp>
+        <p:nvSpPr>
+          <p:cNvPr id="4" name="TextBox 3"/>
           <p:cNvSpPr txBox="1"/>
           <p:nvPr/>
         </p:nvSpPr>
         <p:spPr>
           <a:xfrm>
-            <a:off x="1097280" y="1645920"/>
-            <a:ext cx="10058400" cy="3657600"/>
+            <a:off x="1280160" y="1371600"/>
+            <a:ext cx="7132320" cy="4114800"/>
           </a:xfrm>
           <a:prstGeom prst="rect">
             <a:avLst/>
@@ -3169,6 +3212,7 @@
                 <a:solidFill>
                   <a:srgbClr val="FFFFFF"/>
                 </a:solidFill>
+                <a:latin typeface="Garamond"/>
               </a:defRPr>
             </a:pPr>
             <a:r>
@@ -3178,39 +3222,119 @@
           <a:p>
             <a:pPr>
               <a:spcBef>
-                <a:spcPts val="1500"/>
+                <a:spcPts val="1400"/>
               </a:spcBef>
-              <a:defRPr sz="1800">
-                <a:solidFill>
-                  <a:srgbClr val="B2DFDB"/>
-                </a:solidFill>
-              </a:defRPr>
-            </a:pPr>
-            <a:r>
-              <a:t>An Uncertainty-Aware Decision Framework for Allocating 50,000 Nets Across 50 Northern Districts</a:t>
+              <a:defRPr sz="1700">
+                <a:solidFill>
+                  <a:srgbClr val="F0DCDC"/>
+                </a:solidFill>
+                <a:latin typeface="Candara"/>
+              </a:defRPr>
+            </a:pPr>
+            <a:r>
+              <a:t>An Uncertainty-Aware Decision Framework for Allocating 50,000 Indivisible Nets Across 50 Northern Districts</a:t>
             </a:r>
           </a:p>
           <a:p>
             <a:pPr>
               <a:spcBef>
-                <a:spcPts val="4000"/>
+                <a:spcPts val="2800"/>
               </a:spcBef>
-              <a:defRPr sz="1400">
-                <a:solidFill>
-                  <a:srgbClr val="C8D7E6"/>
-                </a:solidFill>
-              </a:defRPr>
-            </a:pPr>
-            <a:r>
-              <a:t>Advisory Presentation to the National Malaria Elimination Programme (NMEP), Ghana Health Service</a:t>
+              <a:defRPr sz="1300">
+                <a:solidFill>
+                  <a:srgbClr val="C59B27"/>
+                </a:solidFill>
+                <a:latin typeface="Candara"/>
+              </a:defRPr>
+            </a:pPr>
+            <a:r>
+              <a:t>Advisory Presentation to the National Malaria Elimination Programme (NMEP)</a:t>
             </a:r>
             <a:br/>
             <a:r>
-              <a:t>ICS553 Machine Learning Essentials · Group 3 · Ashesi University</a:t>
-            </a:r>
-          </a:p>
-        </p:txBody>
-      </p:sp>
+              <a:t>Ministry of Health, Republic of Ghana</a:t>
+            </a:r>
+            <a:br/>
+            <a:br/>
+            <a:r>
+              <a:t>Group 3 · Master of Science in Intelligent Computing Systems (MICS 2028)</a:t>
+            </a:r>
+            <a:br/>
+            <a:r>
+              <a:t>Ashesi University</a:t>
+            </a:r>
+          </a:p>
+        </p:txBody>
+      </p:sp>
+      <p:sp>
+        <p:nvSpPr>
+          <p:cNvPr id="5" name="Rounded Rectangle 4"/>
+          <p:cNvSpPr/>
+          <p:nvPr/>
+        </p:nvSpPr>
+        <p:spPr>
+          <a:xfrm>
+            <a:off x="8778240" y="2011680"/>
+            <a:ext cx="2560320" cy="2743200"/>
+          </a:xfrm>
+          <a:prstGeom prst="roundRect">
+            <a:avLst/>
+          </a:prstGeom>
+          <a:solidFill>
+            <a:srgbClr val="FFFFFF"/>
+          </a:solidFill>
+          <a:ln w="19050">
+            <a:solidFill>
+              <a:srgbClr val="C59B27"/>
+            </a:solidFill>
+          </a:ln>
+        </p:spPr>
+        <p:style>
+          <a:lnRef idx="1">
+            <a:schemeClr val="accent1"/>
+          </a:lnRef>
+          <a:fillRef idx="3">
+            <a:schemeClr val="accent1"/>
+          </a:fillRef>
+          <a:effectRef idx="2">
+            <a:schemeClr val="accent1"/>
+          </a:effectRef>
+          <a:fontRef idx="minor">
+            <a:schemeClr val="lt1"/>
+          </a:fontRef>
+        </p:style>
+        <p:txBody>
+          <a:bodyPr rtlCol="0" anchor="ctr"/>
+          <a:lstStyle/>
+          <a:p>
+            <a:pPr algn="ctr"/>
+          </a:p>
+        </p:txBody>
+      </p:sp>
+      <p:pic>
+        <p:nvPicPr>
+          <p:cNvPr id="6" name="Picture 5" descr="ashesi_logo.png"/>
+          <p:cNvPicPr>
+            <a:picLocks noChangeAspect="1"/>
+          </p:cNvPicPr>
+          <p:nvPr/>
+        </p:nvPicPr>
+        <p:blipFill>
+          <a:blip r:embed="rId2"/>
+          <a:stretch>
+            <a:fillRect/>
+          </a:stretch>
+        </p:blipFill>
+        <p:spPr>
+          <a:xfrm>
+            <a:off x="8961120" y="2286000"/>
+            <a:ext cx="2194560" cy="1697645"/>
+          </a:xfrm>
+          <a:prstGeom prst="rect">
+            <a:avLst/>
+          </a:prstGeom>
+        </p:spPr>
+      </p:pic>
     </p:spTree>
   </p:cSld>
   <p:clrMapOvr>
@@ -3231,72 +3355,23 @@
       <p:grpSpPr/>
       <p:sp>
         <p:nvSpPr>
-          <p:cNvPr id="2" name="TextBox 1"/>
-          <p:cNvSpPr txBox="1"/>
-          <p:nvPr/>
-        </p:nvSpPr>
-        <p:spPr>
-          <a:xfrm>
-            <a:off x="731520" y="365760"/>
-            <a:ext cx="10728655" cy="822960"/>
+          <p:cNvPr id="2" name="Rectangle 1"/>
+          <p:cNvSpPr/>
+          <p:nvPr/>
+        </p:nvSpPr>
+        <p:spPr>
+          <a:xfrm>
+            <a:off x="0" y="0"/>
+            <a:ext cx="12191695" cy="73152"/>
           </a:xfrm>
           <a:prstGeom prst="rect">
             <a:avLst/>
           </a:prstGeom>
-          <a:noFill/>
-        </p:spPr>
-        <p:txBody>
-          <a:bodyPr wrap="square" lIns="0" tIns="0" rIns="0" bIns="0">
-            <a:spAutoFit/>
-          </a:bodyPr>
-          <a:lstStyle/>
-          <a:p>
-            <a:pPr>
-              <a:defRPr sz="1100" b="1">
-                <a:solidFill>
-                  <a:srgbClr val="009688"/>
-                </a:solidFill>
-              </a:defRPr>
-            </a:pPr>
-            <a:r>
-              <a:t>THEME C POLICY DEFENSE</a:t>
-            </a:r>
-          </a:p>
-          <a:p>
-            <a:pPr>
-              <a:defRPr sz="2200" b="1">
-                <a:solidFill>
-                  <a:srgbClr val="0F2043"/>
-                </a:solidFill>
-              </a:defRPr>
-            </a:pPr>
-            <a:r>
-              <a:t>Deep Dive: The Referral Hospital Trap Explained</a:t>
-            </a:r>
-          </a:p>
-        </p:txBody>
-      </p:sp>
-      <p:sp>
-        <p:nvSpPr>
-          <p:cNvPr id="3" name="Rounded Rectangle 2"/>
-          <p:cNvSpPr/>
-          <p:nvPr/>
-        </p:nvSpPr>
-        <p:spPr>
-          <a:xfrm>
-            <a:off x="731520" y="1371600"/>
-            <a:ext cx="5120640" cy="4846320"/>
-          </a:xfrm>
-          <a:prstGeom prst="roundRect">
-            <a:avLst/>
-          </a:prstGeom>
           <a:solidFill>
-            <a:srgbClr val="F5F7FA"/>
+            <a:srgbClr val="A83F43"/>
           </a:solidFill>
           <a:ln>
-            <a:solidFill>
-              <a:srgbClr val="DCE0E6"/>
-            </a:solidFill>
+            <a:noFill/>
           </a:ln>
         </p:spPr>
         <p:style>
@@ -3323,14 +3398,14 @@
       </p:sp>
       <p:sp>
         <p:nvSpPr>
-          <p:cNvPr id="4" name="TextBox 3"/>
+          <p:cNvPr id="3" name="TextBox 2"/>
           <p:cNvSpPr txBox="1"/>
           <p:nvPr/>
         </p:nvSpPr>
         <p:spPr>
           <a:xfrm>
-            <a:off x="914400" y="1554480"/>
-            <a:ext cx="4754880" cy="4480560"/>
+            <a:off x="731520" y="365760"/>
+            <a:ext cx="9144000" cy="868680"/>
           </a:xfrm>
           <a:prstGeom prst="rect">
             <a:avLst/>
@@ -3338,89 +3413,131 @@
           <a:noFill/>
         </p:spPr>
         <p:txBody>
-          <a:bodyPr wrap="square">
+          <a:bodyPr wrap="square" lIns="0" tIns="0" rIns="0" bIns="0">
             <a:spAutoFit/>
           </a:bodyPr>
           <a:lstStyle/>
           <a:p>
             <a:pPr>
-              <a:defRPr sz="1500" b="1">
-                <a:solidFill>
-                  <a:srgbClr val="C0392B"/>
-                </a:solidFill>
-              </a:defRPr>
-            </a:pPr>
-            <a:r>
-              <a:t>Why Wa (-1,516) &amp; Bolgatanga (-665) Lose Nets</a:t>
-            </a:r>
-          </a:p>
-          <a:p>
-            <a:pPr>
-              <a:spcBef>
-                <a:spcPts val="1200"/>
-              </a:spcBef>
-              <a:defRPr sz="1100">
-                <a:solidFill>
-                  <a:srgbClr val="212121"/>
-                </a:solidFill>
-              </a:defRPr>
-            </a:pPr>
-            <a:r>
-              <a:t>1. Hospital Catchment Distortion: Wa and Bolgatanga host the two regional referral hospitals. Cases are logged at the clinic address, not patient residence!</a:t>
-            </a:r>
-          </a:p>
-          <a:p>
-            <a:pPr>
-              <a:spcBef>
-                <a:spcPts val="1200"/>
-              </a:spcBef>
-              <a:defRPr sz="1100">
-                <a:solidFill>
-                  <a:srgbClr val="212121"/>
-                </a:solidFill>
-              </a:defRPr>
-            </a:pPr>
-            <a:r>
-              <a:t>2. Saturated Baseline Ownership: Upper East has 79.6% net coverage; Upper West has 69.8%. Bolga already has nets in almost every home.</a:t>
-            </a:r>
-          </a:p>
-          <a:p>
-            <a:pPr>
-              <a:spcBef>
-                <a:spcPts val="1200"/>
-              </a:spcBef>
-              <a:defRPr sz="1100">
-                <a:solidFill>
-                  <a:srgbClr val="212121"/>
-                </a:solidFill>
-              </a:defRPr>
-            </a:pPr>
-            <a:r>
-              <a:t>3. Eliminating Waste: Naive allocation gives Bolga 3,015 nets and Wa 2,610 nets. Our model scales them down to honest local community levels.</a:t>
-            </a:r>
-          </a:p>
-        </p:txBody>
-      </p:sp>
-      <p:sp>
-        <p:nvSpPr>
-          <p:cNvPr id="5" name="Rounded Rectangle 4"/>
+              <a:defRPr sz="1000" b="1">
+                <a:solidFill>
+                  <a:srgbClr val="A83F43"/>
+                </a:solidFill>
+                <a:latin typeface="Candara"/>
+              </a:defRPr>
+            </a:pPr>
+            <a:r>
+              <a:t>THEME C POLICY DEFENSE</a:t>
+            </a:r>
+          </a:p>
+          <a:p>
+            <a:pPr>
+              <a:defRPr sz="2300" b="1">
+                <a:solidFill>
+                  <a:srgbClr val="5E1214"/>
+                </a:solidFill>
+                <a:latin typeface="Garamond"/>
+              </a:defRPr>
+            </a:pPr>
+            <a:r>
+              <a:t>Deep Dive: The Referral Hospital Trap Explained</a:t>
+            </a:r>
+          </a:p>
+        </p:txBody>
+      </p:sp>
+      <p:pic>
+        <p:nvPicPr>
+          <p:cNvPr id="4" name="Picture 3" descr="ashesi_logo.png"/>
+          <p:cNvPicPr>
+            <a:picLocks noChangeAspect="1"/>
+          </p:cNvPicPr>
+          <p:nvPr/>
+        </p:nvPicPr>
+        <p:blipFill>
+          <a:blip r:embed="rId2"/>
+          <a:stretch>
+            <a:fillRect/>
+          </a:stretch>
+        </p:blipFill>
+        <p:spPr>
+          <a:xfrm>
+            <a:off x="10789920" y="320040"/>
+            <a:ext cx="886539" cy="685800"/>
+          </a:xfrm>
+          <a:prstGeom prst="rect">
+            <a:avLst/>
+          </a:prstGeom>
+        </p:spPr>
+      </p:pic>
+      <p:sp>
+        <p:nvSpPr>
+          <p:cNvPr id="5" name="TextBox 4"/>
+          <p:cNvSpPr txBox="1"/>
+          <p:nvPr/>
+        </p:nvSpPr>
+        <p:spPr>
+          <a:xfrm>
+            <a:off x="731520" y="6446520"/>
+            <a:ext cx="10728655" cy="274320"/>
+          </a:xfrm>
+          <a:prstGeom prst="rect">
+            <a:avLst/>
+          </a:prstGeom>
+          <a:noFill/>
+        </p:spPr>
+        <p:txBody>
+          <a:bodyPr wrap="none" lIns="0" tIns="0" rIns="0" bIns="0">
+            <a:spAutoFit/>
+          </a:bodyPr>
+          <a:lstStyle/>
+          <a:p>
+            <a:pPr>
+              <a:defRPr sz="900">
+                <a:solidFill>
+                  <a:srgbClr val="5A626A"/>
+                </a:solidFill>
+                <a:latin typeface="Candara"/>
+              </a:defRPr>
+            </a:pPr>
+            <a:r>
+              <a:t>Ashesi University · ICS553 Machine Learning Essentials · Group 3 · Prosit 1 Advisory Brief</a:t>
+            </a:r>
+          </a:p>
+          <a:p>
+            <a:pPr algn="r">
+              <a:defRPr sz="900">
+                <a:solidFill>
+                  <a:srgbClr val="5A626A"/>
+                </a:solidFill>
+                <a:latin typeface="Candara"/>
+              </a:defRPr>
+            </a:pPr>
+            <a:r>
+              <a:t>10</a:t>
+            </a:r>
+          </a:p>
+        </p:txBody>
+      </p:sp>
+      <p:sp>
+        <p:nvSpPr>
+          <p:cNvPr id="6" name="Rounded Rectangle 5"/>
           <p:cNvSpPr/>
           <p:nvPr/>
         </p:nvSpPr>
         <p:spPr>
           <a:xfrm>
-            <a:off x="6309360" y="1371600"/>
+            <a:off x="731520" y="1371600"/>
             <a:ext cx="5120640" cy="4846320"/>
           </a:xfrm>
           <a:prstGeom prst="roundRect">
             <a:avLst/>
           </a:prstGeom>
           <a:solidFill>
-            <a:srgbClr val="F5F7FA"/>
+            <a:srgbClr val="F8F9FA"/>
           </a:solidFill>
           <a:ln>
             <a:solidFill>
-              <a:srgbClr val="DCE0E6"/>
+              <a:srgbClr val="E2E4E8"/>
             </a:solidFill>
           </a:ln>
         </p:spPr>
@@ -3448,13 +3565,13 @@
       </p:sp>
       <p:sp>
         <p:nvSpPr>
-          <p:cNvPr id="6" name="TextBox 5"/>
+          <p:cNvPr id="7" name="TextBox 6"/>
           <p:cNvSpPr txBox="1"/>
           <p:nvPr/>
         </p:nvSpPr>
         <p:spPr>
           <a:xfrm>
-            <a:off x="6492240" y="1554480"/>
+            <a:off x="914400" y="1554480"/>
             <a:ext cx="4754880" cy="4480560"/>
           </a:xfrm>
           <a:prstGeom prst="rect">
@@ -3469,14 +3586,15 @@
           <a:lstStyle/>
           <a:p>
             <a:pPr>
-              <a:defRPr sz="1500" b="1">
-                <a:solidFill>
-                  <a:srgbClr val="009688"/>
-                </a:solidFill>
-              </a:defRPr>
-            </a:pPr>
-            <a:r>
-              <a:t>Why Tamale (+1,692) &amp; Sagnarigu (+1,012) Gain Nets</a:t>
+              <a:defRPr sz="1600" b="1">
+                <a:solidFill>
+                  <a:srgbClr val="B33939"/>
+                </a:solidFill>
+                <a:latin typeface="Garamond"/>
+              </a:defRPr>
+            </a:pPr>
+            <a:r>
+              <a:t>Why Wa (-1,516) &amp; Bolgatanga (-665) Lose Nets</a:t>
             </a:r>
           </a:p>
           <a:p>
@@ -3486,12 +3604,13 @@
               </a:spcBef>
               <a:defRPr sz="1100">
                 <a:solidFill>
-                  <a:srgbClr val="212121"/>
-                </a:solidFill>
-              </a:defRPr>
-            </a:pPr>
-            <a:r>
-              <a:t>1. Massive Population at Risk: Tamale has ~255,000 residents; Sagnarigu has ~168,000 residents (the largest urban agglomeration in the north).</a:t>
+                  <a:srgbClr val="1E2022"/>
+                </a:solidFill>
+                <a:latin typeface="Candara"/>
+              </a:defRPr>
+            </a:pPr>
+            <a:r>
+              <a:t>1. Hospital Catchment Distortion: Wa and Bolgatanga host the two regional referral hospitals. Cases are logged at the clinic address, not patient residence!</a:t>
             </a:r>
           </a:p>
           <a:p>
@@ -3501,12 +3620,13 @@
               </a:spcBef>
               <a:defRPr sz="1100">
                 <a:solidFill>
-                  <a:srgbClr val="212121"/>
-                </a:solidFill>
-              </a:defRPr>
-            </a:pPr>
-            <a:r>
-              <a:t>2. Critical Unmet Need Gap: Northern Region has only 67.7% baseline coverage. The absolute number of unprotected people is highest here.</a:t>
+                  <a:srgbClr val="1E2022"/>
+                </a:solidFill>
+                <a:latin typeface="Candara"/>
+              </a:defRPr>
+            </a:pPr>
+            <a:r>
+              <a:t>2. Saturated Baseline Ownership: Upper East has 79.6% net coverage; Upper West has 69.8%. Bolga already has nets in almost every home.</a:t>
             </a:r>
           </a:p>
           <a:p>
@@ -3516,8 +3636,138 @@
               </a:spcBef>
               <a:defRPr sz="1100">
                 <a:solidFill>
-                  <a:srgbClr val="212121"/>
-                </a:solidFill>
+                  <a:srgbClr val="1E2022"/>
+                </a:solidFill>
+                <a:latin typeface="Candara"/>
+              </a:defRPr>
+            </a:pPr>
+            <a:r>
+              <a:t>3. Eliminating Waste: Naive allocation gives Bolga 3,015 nets and Wa 2,610 nets. Our model scales them down to honest local community levels.</a:t>
+            </a:r>
+          </a:p>
+        </p:txBody>
+      </p:sp>
+      <p:sp>
+        <p:nvSpPr>
+          <p:cNvPr id="8" name="Rounded Rectangle 7"/>
+          <p:cNvSpPr/>
+          <p:nvPr/>
+        </p:nvSpPr>
+        <p:spPr>
+          <a:xfrm>
+            <a:off x="6309360" y="1371600"/>
+            <a:ext cx="5120640" cy="4846320"/>
+          </a:xfrm>
+          <a:prstGeom prst="roundRect">
+            <a:avLst/>
+          </a:prstGeom>
+          <a:solidFill>
+            <a:srgbClr val="F8F9FA"/>
+          </a:solidFill>
+          <a:ln>
+            <a:solidFill>
+              <a:srgbClr val="E2E4E8"/>
+            </a:solidFill>
+          </a:ln>
+        </p:spPr>
+        <p:style>
+          <a:lnRef idx="1">
+            <a:schemeClr val="accent1"/>
+          </a:lnRef>
+          <a:fillRef idx="3">
+            <a:schemeClr val="accent1"/>
+          </a:fillRef>
+          <a:effectRef idx="2">
+            <a:schemeClr val="accent1"/>
+          </a:effectRef>
+          <a:fontRef idx="minor">
+            <a:schemeClr val="lt1"/>
+          </a:fontRef>
+        </p:style>
+        <p:txBody>
+          <a:bodyPr rtlCol="0" anchor="ctr"/>
+          <a:lstStyle/>
+          <a:p>
+            <a:pPr algn="ctr"/>
+          </a:p>
+        </p:txBody>
+      </p:sp>
+      <p:sp>
+        <p:nvSpPr>
+          <p:cNvPr id="9" name="TextBox 8"/>
+          <p:cNvSpPr txBox="1"/>
+          <p:nvPr/>
+        </p:nvSpPr>
+        <p:spPr>
+          <a:xfrm>
+            <a:off x="6492240" y="1554480"/>
+            <a:ext cx="4754880" cy="4480560"/>
+          </a:xfrm>
+          <a:prstGeom prst="rect">
+            <a:avLst/>
+          </a:prstGeom>
+          <a:noFill/>
+        </p:spPr>
+        <p:txBody>
+          <a:bodyPr wrap="square">
+            <a:spAutoFit/>
+          </a:bodyPr>
+          <a:lstStyle/>
+          <a:p>
+            <a:pPr>
+              <a:defRPr sz="1600" b="1">
+                <a:solidFill>
+                  <a:srgbClr val="2B6CB0"/>
+                </a:solidFill>
+                <a:latin typeface="Garamond"/>
+              </a:defRPr>
+            </a:pPr>
+            <a:r>
+              <a:t>Why Tamale (+1,692) &amp; Sagnarigu (+1,012) Gain Nets</a:t>
+            </a:r>
+          </a:p>
+          <a:p>
+            <a:pPr>
+              <a:spcBef>
+                <a:spcPts val="1200"/>
+              </a:spcBef>
+              <a:defRPr sz="1100">
+                <a:solidFill>
+                  <a:srgbClr val="1E2022"/>
+                </a:solidFill>
+                <a:latin typeface="Candara"/>
+              </a:defRPr>
+            </a:pPr>
+            <a:r>
+              <a:t>1. Massive Population at Risk: Tamale has ~255,000 residents; Sagnarigu has ~168,000 residents (the largest urban agglomeration in the north).</a:t>
+            </a:r>
+          </a:p>
+          <a:p>
+            <a:pPr>
+              <a:spcBef>
+                <a:spcPts val="1200"/>
+              </a:spcBef>
+              <a:defRPr sz="1100">
+                <a:solidFill>
+                  <a:srgbClr val="1E2022"/>
+                </a:solidFill>
+                <a:latin typeface="Candara"/>
+              </a:defRPr>
+            </a:pPr>
+            <a:r>
+              <a:t>2. Critical Unmet Need Gap: Northern Region has only 67.7% baseline coverage. The absolute number of unprotected people is highest here.</a:t>
+            </a:r>
+          </a:p>
+          <a:p>
+            <a:pPr>
+              <a:spcBef>
+                <a:spcPts val="1200"/>
+              </a:spcBef>
+              <a:defRPr sz="1100">
+                <a:solidFill>
+                  <a:srgbClr val="1E2022"/>
+                </a:solidFill>
+                <a:latin typeface="Candara"/>
               </a:defRPr>
             </a:pPr>
             <a:r>
@@ -3546,14 +3796,57 @@
       <p:grpSpPr/>
       <p:sp>
         <p:nvSpPr>
-          <p:cNvPr id="2" name="TextBox 1"/>
+          <p:cNvPr id="2" name="Rectangle 1"/>
+          <p:cNvSpPr/>
+          <p:nvPr/>
+        </p:nvSpPr>
+        <p:spPr>
+          <a:xfrm>
+            <a:off x="0" y="0"/>
+            <a:ext cx="12191695" cy="73152"/>
+          </a:xfrm>
+          <a:prstGeom prst="rect">
+            <a:avLst/>
+          </a:prstGeom>
+          <a:solidFill>
+            <a:srgbClr val="A83F43"/>
+          </a:solidFill>
+          <a:ln>
+            <a:noFill/>
+          </a:ln>
+        </p:spPr>
+        <p:style>
+          <a:lnRef idx="1">
+            <a:schemeClr val="accent1"/>
+          </a:lnRef>
+          <a:fillRef idx="3">
+            <a:schemeClr val="accent1"/>
+          </a:fillRef>
+          <a:effectRef idx="2">
+            <a:schemeClr val="accent1"/>
+          </a:effectRef>
+          <a:fontRef idx="minor">
+            <a:schemeClr val="lt1"/>
+          </a:fontRef>
+        </p:style>
+        <p:txBody>
+          <a:bodyPr rtlCol="0" anchor="ctr"/>
+          <a:lstStyle/>
+          <a:p>
+            <a:pPr algn="ctr"/>
+          </a:p>
+        </p:txBody>
+      </p:sp>
+      <p:sp>
+        <p:nvSpPr>
+          <p:cNvPr id="3" name="TextBox 2"/>
           <p:cNvSpPr txBox="1"/>
           <p:nvPr/>
         </p:nvSpPr>
         <p:spPr>
           <a:xfrm>
             <a:off x="731520" y="365760"/>
-            <a:ext cx="10728655" cy="822960"/>
+            <a:ext cx="9144000" cy="868680"/>
           </a:xfrm>
           <a:prstGeom prst="rect">
             <a:avLst/>
@@ -3567,10 +3860,11 @@
           <a:lstStyle/>
           <a:p>
             <a:pPr>
-              <a:defRPr sz="1100" b="1">
-                <a:solidFill>
-                  <a:srgbClr val="009688"/>
-                </a:solidFill>
+              <a:defRPr sz="1000" b="1">
+                <a:solidFill>
+                  <a:srgbClr val="A83F43"/>
+                </a:solidFill>
+                <a:latin typeface="Candara"/>
               </a:defRPr>
             </a:pPr>
             <a:r>
@@ -3579,10 +3873,11 @@
           </a:p>
           <a:p>
             <a:pPr>
-              <a:defRPr sz="2200" b="1">
-                <a:solidFill>
-                  <a:srgbClr val="0F2043"/>
-                </a:solidFill>
+              <a:defRPr sz="2300" b="1">
+                <a:solidFill>
+                  <a:srgbClr val="5E1214"/>
+                </a:solidFill>
+                <a:latin typeface="Garamond"/>
               </a:defRPr>
             </a:pPr>
             <a:r>
@@ -3591,9 +3886,82 @@
           </a:p>
         </p:txBody>
       </p:sp>
-      <p:sp>
-        <p:nvSpPr>
-          <p:cNvPr id="3" name="TextBox 2"/>
+      <p:pic>
+        <p:nvPicPr>
+          <p:cNvPr id="4" name="Picture 3" descr="ashesi_logo.png"/>
+          <p:cNvPicPr>
+            <a:picLocks noChangeAspect="1"/>
+          </p:cNvPicPr>
+          <p:nvPr/>
+        </p:nvPicPr>
+        <p:blipFill>
+          <a:blip r:embed="rId2"/>
+          <a:stretch>
+            <a:fillRect/>
+          </a:stretch>
+        </p:blipFill>
+        <p:spPr>
+          <a:xfrm>
+            <a:off x="10789920" y="320040"/>
+            <a:ext cx="886539" cy="685800"/>
+          </a:xfrm>
+          <a:prstGeom prst="rect">
+            <a:avLst/>
+          </a:prstGeom>
+        </p:spPr>
+      </p:pic>
+      <p:sp>
+        <p:nvSpPr>
+          <p:cNvPr id="5" name="TextBox 4"/>
+          <p:cNvSpPr txBox="1"/>
+          <p:nvPr/>
+        </p:nvSpPr>
+        <p:spPr>
+          <a:xfrm>
+            <a:off x="731520" y="6446520"/>
+            <a:ext cx="10728655" cy="274320"/>
+          </a:xfrm>
+          <a:prstGeom prst="rect">
+            <a:avLst/>
+          </a:prstGeom>
+          <a:noFill/>
+        </p:spPr>
+        <p:txBody>
+          <a:bodyPr wrap="none" lIns="0" tIns="0" rIns="0" bIns="0">
+            <a:spAutoFit/>
+          </a:bodyPr>
+          <a:lstStyle/>
+          <a:p>
+            <a:pPr>
+              <a:defRPr sz="900">
+                <a:solidFill>
+                  <a:srgbClr val="5A626A"/>
+                </a:solidFill>
+                <a:latin typeface="Candara"/>
+              </a:defRPr>
+            </a:pPr>
+            <a:r>
+              <a:t>Ashesi University · ICS553 Machine Learning Essentials · Group 3 · Prosit 1 Advisory Brief</a:t>
+            </a:r>
+          </a:p>
+          <a:p>
+            <a:pPr algn="r">
+              <a:defRPr sz="900">
+                <a:solidFill>
+                  <a:srgbClr val="5A626A"/>
+                </a:solidFill>
+                <a:latin typeface="Candara"/>
+              </a:defRPr>
+            </a:pPr>
+            <a:r>
+              <a:t>11</a:t>
+            </a:r>
+          </a:p>
+        </p:txBody>
+      </p:sp>
+      <p:sp>
+        <p:nvSpPr>
+          <p:cNvPr id="6" name="TextBox 5"/>
           <p:cNvSpPr txBox="1"/>
           <p:nvPr/>
         </p:nvSpPr>
@@ -3616,8 +3984,9 @@
             <a:pPr>
               <a:defRPr sz="1800" b="1">
                 <a:solidFill>
-                  <a:srgbClr val="0F2043"/>
-                </a:solidFill>
+                  <a:srgbClr val="5E1214"/>
+                </a:solidFill>
+                <a:latin typeface="Garamond"/>
               </a:defRPr>
             </a:pPr>
             <a:r>
@@ -3633,8 +4002,9 @@
             <a:r>
               <a:rPr b="1" sz="1300">
                 <a:solidFill>
-                  <a:srgbClr val="009688"/>
-                </a:solidFill>
+                  <a:srgbClr val="A83F43"/>
+                </a:solidFill>
+                <a:latin typeface="Candara"/>
               </a:rPr>
               <a:t>Phase 1: Regional Warehousing &amp; Staging (Weeks 1-2)
 </a:t>
@@ -3642,8 +4012,9 @@
             <a:r>
               <a:rPr sz="1100">
                 <a:solidFill>
-                  <a:srgbClr val="212121"/>
-                </a:solidFill>
+                  <a:srgbClr val="1E2022"/>
+                </a:solidFill>
+                <a:latin typeface="Candara"/>
               </a:rPr>
               <a:t>Consignments dispatched to Tamale (24,980), Bolgatanga (17,547), and Wa (7,473) central medical stores.</a:t>
             </a:r>
@@ -3657,8 +4028,9 @@
             <a:r>
               <a:rPr b="1" sz="1300">
                 <a:solidFill>
-                  <a:srgbClr val="009688"/>
-                </a:solidFill>
+                  <a:srgbClr val="A83F43"/>
+                </a:solidFill>
+                <a:latin typeface="Candara"/>
               </a:rPr>
               <a:t>Phase 2: Last-Mile Delivery via CHPS Compounds (Weeks 3-4)
 </a:t>
@@ -3666,8 +4038,9 @@
             <a:r>
               <a:rPr sz="1100">
                 <a:solidFill>
-                  <a:srgbClr val="212121"/>
-                </a:solidFill>
+                  <a:srgbClr val="1E2022"/>
+                </a:solidFill>
+                <a:latin typeface="Candara"/>
               </a:rPr>
               <a:t>Bypassing regional hospital gates to distribute directly through Community-Based Health Planning and Services (CHPS), prioritizing pregnant women and children under 5.</a:t>
             </a:r>
@@ -3681,8 +4054,9 @@
             <a:r>
               <a:rPr b="1" sz="1300">
                 <a:solidFill>
-                  <a:srgbClr val="009688"/>
-                </a:solidFill>
+                  <a:srgbClr val="A83F43"/>
+                </a:solidFill>
+                <a:latin typeface="Candara"/>
               </a:rPr>
               <a:t>Phase 3: Digital Tracking &amp; Traceability (Weeks 4-6)
 </a:t>
@@ -3690,8 +4064,9 @@
             <a:r>
               <a:rPr sz="1100">
                 <a:solidFill>
-                  <a:srgbClr val="212121"/>
-                </a:solidFill>
+                  <a:srgbClr val="1E2022"/>
+                </a:solidFill>
+                <a:latin typeface="Candara"/>
               </a:rPr>
               <a:t>Barcode scanning of bale deliveries at district health directorates to eliminate supply leakage and diversion.</a:t>
             </a:r>
@@ -3705,8 +4080,9 @@
             <a:r>
               <a:rPr b="1" sz="1300">
                 <a:solidFill>
-                  <a:srgbClr val="009688"/>
-                </a:solidFill>
+                  <a:srgbClr val="A83F43"/>
+                </a:solidFill>
+                <a:latin typeface="Candara"/>
               </a:rPr>
               <a:t>Phase 4: 6-Month Post-Distribution Audit (Month 6)
 </a:t>
@@ -3714,8 +4090,9 @@
             <a:r>
               <a:rPr sz="1100">
                 <a:solidFill>
-                  <a:srgbClr val="212121"/>
-                </a:solidFill>
+                  <a:srgbClr val="1E2022"/>
+                </a:solidFill>
+                <a:latin typeface="Candara"/>
               </a:rPr>
               <a:t>Conduct rapid two-stage cluster surveys in recipient communities to evaluate net hanging rates, physical integrity, and local parasitaemia decline.</a:t>
             </a:r>
@@ -3742,14 +4119,57 @@
       <p:grpSpPr/>
       <p:sp>
         <p:nvSpPr>
-          <p:cNvPr id="2" name="TextBox 1"/>
+          <p:cNvPr id="2" name="Rectangle 1"/>
+          <p:cNvSpPr/>
+          <p:nvPr/>
+        </p:nvSpPr>
+        <p:spPr>
+          <a:xfrm>
+            <a:off x="0" y="0"/>
+            <a:ext cx="12191695" cy="73152"/>
+          </a:xfrm>
+          <a:prstGeom prst="rect">
+            <a:avLst/>
+          </a:prstGeom>
+          <a:solidFill>
+            <a:srgbClr val="A83F43"/>
+          </a:solidFill>
+          <a:ln>
+            <a:noFill/>
+          </a:ln>
+        </p:spPr>
+        <p:style>
+          <a:lnRef idx="1">
+            <a:schemeClr val="accent1"/>
+          </a:lnRef>
+          <a:fillRef idx="3">
+            <a:schemeClr val="accent1"/>
+          </a:fillRef>
+          <a:effectRef idx="2">
+            <a:schemeClr val="accent1"/>
+          </a:effectRef>
+          <a:fontRef idx="minor">
+            <a:schemeClr val="lt1"/>
+          </a:fontRef>
+        </p:style>
+        <p:txBody>
+          <a:bodyPr rtlCol="0" anchor="ctr"/>
+          <a:lstStyle/>
+          <a:p>
+            <a:pPr algn="ctr"/>
+          </a:p>
+        </p:txBody>
+      </p:sp>
+      <p:sp>
+        <p:nvSpPr>
+          <p:cNvPr id="3" name="TextBox 2"/>
           <p:cNvSpPr txBox="1"/>
           <p:nvPr/>
         </p:nvSpPr>
         <p:spPr>
           <a:xfrm>
             <a:off x="731520" y="365760"/>
-            <a:ext cx="10728655" cy="822960"/>
+            <a:ext cx="9144000" cy="868680"/>
           </a:xfrm>
           <a:prstGeom prst="rect">
             <a:avLst/>
@@ -3763,10 +4183,11 @@
           <a:lstStyle/>
           <a:p>
             <a:pPr>
-              <a:defRPr sz="1100" b="1">
-                <a:solidFill>
-                  <a:srgbClr val="009688"/>
-                </a:solidFill>
+              <a:defRPr sz="1000" b="1">
+                <a:solidFill>
+                  <a:srgbClr val="A83F43"/>
+                </a:solidFill>
+                <a:latin typeface="Candara"/>
               </a:defRPr>
             </a:pPr>
             <a:r>
@@ -3775,10 +4196,11 @@
           </a:p>
           <a:p>
             <a:pPr>
-              <a:defRPr sz="2200" b="1">
-                <a:solidFill>
-                  <a:srgbClr val="0F2043"/>
-                </a:solidFill>
+              <a:defRPr sz="2300" b="1">
+                <a:solidFill>
+                  <a:srgbClr val="5E1214"/>
+                </a:solidFill>
+                <a:latin typeface="Garamond"/>
               </a:defRPr>
             </a:pPr>
             <a:r>
@@ -3787,9 +4209,82 @@
           </a:p>
         </p:txBody>
       </p:sp>
-      <p:sp>
-        <p:nvSpPr>
-          <p:cNvPr id="3" name="TextBox 2"/>
+      <p:pic>
+        <p:nvPicPr>
+          <p:cNvPr id="4" name="Picture 3" descr="ashesi_logo.png"/>
+          <p:cNvPicPr>
+            <a:picLocks noChangeAspect="1"/>
+          </p:cNvPicPr>
+          <p:nvPr/>
+        </p:nvPicPr>
+        <p:blipFill>
+          <a:blip r:embed="rId2"/>
+          <a:stretch>
+            <a:fillRect/>
+          </a:stretch>
+        </p:blipFill>
+        <p:spPr>
+          <a:xfrm>
+            <a:off x="10789920" y="320040"/>
+            <a:ext cx="886539" cy="685800"/>
+          </a:xfrm>
+          <a:prstGeom prst="rect">
+            <a:avLst/>
+          </a:prstGeom>
+        </p:spPr>
+      </p:pic>
+      <p:sp>
+        <p:nvSpPr>
+          <p:cNvPr id="5" name="TextBox 4"/>
+          <p:cNvSpPr txBox="1"/>
+          <p:nvPr/>
+        </p:nvSpPr>
+        <p:spPr>
+          <a:xfrm>
+            <a:off x="731520" y="6446520"/>
+            <a:ext cx="10728655" cy="274320"/>
+          </a:xfrm>
+          <a:prstGeom prst="rect">
+            <a:avLst/>
+          </a:prstGeom>
+          <a:noFill/>
+        </p:spPr>
+        <p:txBody>
+          <a:bodyPr wrap="none" lIns="0" tIns="0" rIns="0" bIns="0">
+            <a:spAutoFit/>
+          </a:bodyPr>
+          <a:lstStyle/>
+          <a:p>
+            <a:pPr>
+              <a:defRPr sz="900">
+                <a:solidFill>
+                  <a:srgbClr val="5A626A"/>
+                </a:solidFill>
+                <a:latin typeface="Candara"/>
+              </a:defRPr>
+            </a:pPr>
+            <a:r>
+              <a:t>Ashesi University · ICS553 Machine Learning Essentials · Group 3 · Prosit 1 Advisory Brief</a:t>
+            </a:r>
+          </a:p>
+          <a:p>
+            <a:pPr algn="r">
+              <a:defRPr sz="900">
+                <a:solidFill>
+                  <a:srgbClr val="5A626A"/>
+                </a:solidFill>
+                <a:latin typeface="Candara"/>
+              </a:defRPr>
+            </a:pPr>
+            <a:r>
+              <a:t>12</a:t>
+            </a:r>
+          </a:p>
+        </p:txBody>
+      </p:sp>
+      <p:sp>
+        <p:nvSpPr>
+          <p:cNvPr id="6" name="TextBox 5"/>
           <p:cNvSpPr txBox="1"/>
           <p:nvPr/>
         </p:nvSpPr>
@@ -3812,8 +4307,9 @@
             <a:pPr>
               <a:defRPr sz="1600" b="1">
                 <a:solidFill>
-                  <a:srgbClr val="0F2043"/>
-                </a:solidFill>
+                  <a:srgbClr val="5E1214"/>
+                </a:solidFill>
+                <a:latin typeface="Garamond"/>
               </a:defRPr>
             </a:pPr>
             <a:r>
@@ -3829,16 +4325,18 @@
             <a:r>
               <a:rPr b="1" sz="1100">
                 <a:solidFill>
-                  <a:srgbClr val="0F2043"/>
-                </a:solidFill>
+                  <a:srgbClr val="A83F43"/>
+                </a:solidFill>
+                <a:latin typeface="Candara"/>
               </a:rPr>
               <a:t>Examiner: 'Why not use Poisson regression?'  </a:t>
             </a:r>
             <a:r>
               <a:rPr sz="1000">
                 <a:solidFill>
-                  <a:srgbClr val="212121"/>
-                </a:solidFill>
+                  <a:srgbClr val="1E2022"/>
+                </a:solidFill>
+                <a:latin typeface="Candara"/>
               </a:rPr>
               <a:t>Answer: In northern Ghana, Variance/Mean is 77,183. Poisson assumes 1.0, underestimating outbreak spread by 278x. Negative Binomial (alpha = 0.2677) accommodates this heavy tail and beats Poisson by 2.39M AIC.</a:t>
             </a:r>
@@ -3852,16 +4350,18 @@
             <a:r>
               <a:rPr b="1" sz="1100">
                 <a:solidFill>
-                  <a:srgbClr val="0F2043"/>
-                </a:solidFill>
+                  <a:srgbClr val="A83F43"/>
+                </a:solidFill>
+                <a:latin typeface="Candara"/>
               </a:rPr>
               <a:t>Examiner: 'Why did naive bootstrap fail?'  </a:t>
             </a:r>
             <a:r>
               <a:rPr sz="1000">
                 <a:solidFill>
-                  <a:srgbClr val="212121"/>
-                </a:solidFill>
+                  <a:srgbClr val="1E2022"/>
+                </a:solidFill>
+                <a:latin typeface="Candara"/>
               </a:rPr>
               <a:t>Answer: DHS data is clustered by village. Naive bootstrap pretends households are independent, shrinking the CI to 7.17 pp. Two-stage cluster bootstrap gives an honest 15.20 pp interval (DEFF = 4.50).</a:t>
             </a:r>
@@ -3875,16 +4375,18 @@
             <a:r>
               <a:rPr b="1" sz="1100">
                 <a:solidFill>
-                  <a:srgbClr val="0F2043"/>
-                </a:solidFill>
+                  <a:srgbClr val="A83F43"/>
+                </a:solidFill>
+                <a:latin typeface="Candara"/>
               </a:rPr>
               <a:t>Examiner: 'Why cut nets from Bolgatanga when it has the highest case count?'  </a:t>
             </a:r>
             <a:r>
               <a:rPr sz="1000">
                 <a:solidFill>
-                  <a:srgbClr val="212121"/>
-                </a:solidFill>
+                  <a:srgbClr val="1E2022"/>
+                </a:solidFill>
+                <a:latin typeface="Candara"/>
               </a:rPr>
               <a:t>Answer: Bolgatanga Regional Hospital logs cases from surrounding rural districts. Furthermore, Upper East already has 79.6% net coverage. Handing thousands more nets to Bolga causes waste; our model targets true community unmet need.</a:t>
             </a:r>
@@ -3898,16 +4400,18 @@
             <a:r>
               <a:rPr b="1" sz="1100">
                 <a:solidFill>
-                  <a:srgbClr val="0F2043"/>
-                </a:solidFill>
+                  <a:srgbClr val="A83F43"/>
+                </a:solidFill>
+                <a:latin typeface="Candara"/>
               </a:rPr>
               <a:t>Examiner: 'What if your budget is cut by 50% to 25,000 nets?'  </a:t>
             </a:r>
             <a:r>
               <a:rPr sz="1000">
                 <a:solidFill>
-                  <a:srgbClr val="212121"/>
-                </a:solidFill>
+                  <a:srgbClr val="1E2022"/>
+                </a:solidFill>
+                <a:latin typeface="Candara"/>
               </a:rPr>
               <a:t>Answer: The priority ranking is invariant. Because Hamilton apportionment scales linearly with relative need weights, the district priority hierarchy remains identical.</a:t>
             </a:r>
@@ -3934,72 +4438,23 @@
       <p:grpSpPr/>
       <p:sp>
         <p:nvSpPr>
-          <p:cNvPr id="2" name="TextBox 1"/>
-          <p:cNvSpPr txBox="1"/>
-          <p:nvPr/>
-        </p:nvSpPr>
-        <p:spPr>
-          <a:xfrm>
-            <a:off x="731520" y="365760"/>
-            <a:ext cx="10728655" cy="822960"/>
+          <p:cNvPr id="2" name="Rectangle 1"/>
+          <p:cNvSpPr/>
+          <p:nvPr/>
+        </p:nvSpPr>
+        <p:spPr>
+          <a:xfrm>
+            <a:off x="0" y="0"/>
+            <a:ext cx="12191695" cy="73152"/>
           </a:xfrm>
           <a:prstGeom prst="rect">
             <a:avLst/>
           </a:prstGeom>
-          <a:noFill/>
-        </p:spPr>
-        <p:txBody>
-          <a:bodyPr wrap="square" lIns="0" tIns="0" rIns="0" bIns="0">
-            <a:spAutoFit/>
-          </a:bodyPr>
-          <a:lstStyle/>
-          <a:p>
-            <a:pPr>
-              <a:defRPr sz="1100" b="1">
-                <a:solidFill>
-                  <a:srgbClr val="009688"/>
-                </a:solidFill>
-              </a:defRPr>
-            </a:pPr>
-            <a:r>
-              <a:t>EXECUTIVE SUMMARY</a:t>
-            </a:r>
-          </a:p>
-          <a:p>
-            <a:pPr>
-              <a:defRPr sz="2200" b="1">
-                <a:solidFill>
-                  <a:srgbClr val="0F2043"/>
-                </a:solidFill>
-              </a:defRPr>
-            </a:pPr>
-            <a:r>
-              <a:t>The Decision Context: Allocating 50,000 Indivisible Nets</a:t>
-            </a:r>
-          </a:p>
-        </p:txBody>
-      </p:sp>
-      <p:sp>
-        <p:nvSpPr>
-          <p:cNvPr id="3" name="Rounded Rectangle 2"/>
-          <p:cNvSpPr/>
-          <p:nvPr/>
-        </p:nvSpPr>
-        <p:spPr>
-          <a:xfrm>
-            <a:off x="731520" y="1371600"/>
-            <a:ext cx="5120640" cy="4846320"/>
-          </a:xfrm>
-          <a:prstGeom prst="roundRect">
-            <a:avLst/>
-          </a:prstGeom>
           <a:solidFill>
-            <a:srgbClr val="F5F7FA"/>
+            <a:srgbClr val="A83F43"/>
           </a:solidFill>
           <a:ln>
-            <a:solidFill>
-              <a:srgbClr val="DCE0E6"/>
-            </a:solidFill>
+            <a:noFill/>
           </a:ln>
         </p:spPr>
         <p:style>
@@ -4026,14 +4481,14 @@
       </p:sp>
       <p:sp>
         <p:nvSpPr>
-          <p:cNvPr id="4" name="TextBox 3"/>
+          <p:cNvPr id="3" name="TextBox 2"/>
           <p:cNvSpPr txBox="1"/>
           <p:nvPr/>
         </p:nvSpPr>
         <p:spPr>
           <a:xfrm>
-            <a:off x="1005840" y="1554480"/>
-            <a:ext cx="4572000" cy="4389120"/>
+            <a:off x="731520" y="365760"/>
+            <a:ext cx="9144000" cy="868680"/>
           </a:xfrm>
           <a:prstGeom prst="rect">
             <a:avLst/>
@@ -4041,136 +4496,131 @@
           <a:noFill/>
         </p:spPr>
         <p:txBody>
-          <a:bodyPr wrap="square">
+          <a:bodyPr wrap="square" lIns="0" tIns="0" rIns="0" bIns="0">
             <a:spAutoFit/>
           </a:bodyPr>
           <a:lstStyle/>
           <a:p>
             <a:pPr>
-              <a:defRPr sz="1600" b="1">
-                <a:solidFill>
-                  <a:srgbClr val="0F2043"/>
-                </a:solidFill>
-              </a:defRPr>
-            </a:pPr>
-            <a:r>
-              <a:t>Operational Parameters &amp; Constraints</a:t>
-            </a:r>
-          </a:p>
-          <a:p>
-            <a:pPr>
-              <a:spcBef>
-                <a:spcPts val="1200"/>
-              </a:spcBef>
-            </a:pPr>
-            <a:r>
-              <a:rPr b="1" sz="1200">
-                <a:solidFill>
-                  <a:srgbClr val="0F2043"/>
-                </a:solidFill>
-              </a:rPr>
-              <a:t>• Resource Ceiling:</a:t>
-            </a:r>
-            <a:r>
-              <a:rPr sz="1200">
-                <a:solidFill>
-                  <a:srgbClr val="212121"/>
-                </a:solidFill>
-              </a:rPr>
-              <a:t> Exactly 50,000 long-lasting ITNs available for northern Ghana.</a:t>
-            </a:r>
-          </a:p>
-          <a:p>
-            <a:pPr>
-              <a:spcBef>
-                <a:spcPts val="1200"/>
-              </a:spcBef>
-            </a:pPr>
-            <a:r>
-              <a:rPr b="1" sz="1200">
-                <a:solidFill>
-                  <a:srgbClr val="0F2043"/>
-                </a:solidFill>
-              </a:rPr>
-              <a:t>• Target Unit:</a:t>
-            </a:r>
-            <a:r>
-              <a:rPr sz="1200">
-                <a:solidFill>
-                  <a:srgbClr val="212121"/>
-                </a:solidFill>
-              </a:rPr>
-              <a:t> 50 administrative districts across Northern, Upper East, and Upper West regions.</a:t>
-            </a:r>
-          </a:p>
-          <a:p>
-            <a:pPr>
-              <a:spcBef>
-                <a:spcPts val="1200"/>
-              </a:spcBef>
-            </a:pPr>
-            <a:r>
-              <a:rPr b="1" sz="1200">
-                <a:solidFill>
-                  <a:srgbClr val="0F2043"/>
-                </a:solidFill>
-              </a:rPr>
-              <a:t>• Indivisibility:</a:t>
-            </a:r>
-            <a:r>
-              <a:rPr sz="1200">
-                <a:solidFill>
-                  <a:srgbClr val="212121"/>
-                </a:solidFill>
-              </a:rPr>
-              <a:t> Integer allocations required (no fractional nets; Hamilton apportionment).</a:t>
-            </a:r>
-          </a:p>
-          <a:p>
-            <a:pPr>
-              <a:spcBef>
-                <a:spcPts val="1200"/>
-              </a:spcBef>
-            </a:pPr>
-            <a:r>
-              <a:rPr b="1" sz="1200">
-                <a:solidFill>
-                  <a:srgbClr val="0F2043"/>
-                </a:solidFill>
-              </a:rPr>
-              <a:t>• Asymmetric Loss:</a:t>
-            </a:r>
-            <a:r>
-              <a:rPr sz="1200">
-                <a:solidFill>
-                  <a:srgbClr val="212121"/>
-                </a:solidFill>
-              </a:rPr>
-              <a:t> Under-allocating to an epidemic zone costs human lives; over-allocating only incurs marginal warehousing costs.</a:t>
-            </a:r>
-          </a:p>
-        </p:txBody>
-      </p:sp>
-      <p:sp>
-        <p:nvSpPr>
-          <p:cNvPr id="5" name="Rounded Rectangle 4"/>
+              <a:defRPr sz="1000" b="1">
+                <a:solidFill>
+                  <a:srgbClr val="A83F43"/>
+                </a:solidFill>
+                <a:latin typeface="Candara"/>
+              </a:defRPr>
+            </a:pPr>
+            <a:r>
+              <a:t>EXECUTIVE SUMMARY</a:t>
+            </a:r>
+          </a:p>
+          <a:p>
+            <a:pPr>
+              <a:defRPr sz="2300" b="1">
+                <a:solidFill>
+                  <a:srgbClr val="5E1214"/>
+                </a:solidFill>
+                <a:latin typeface="Garamond"/>
+              </a:defRPr>
+            </a:pPr>
+            <a:r>
+              <a:t>The Decision Context: Allocating 50,000 Indivisible Nets</a:t>
+            </a:r>
+          </a:p>
+        </p:txBody>
+      </p:sp>
+      <p:pic>
+        <p:nvPicPr>
+          <p:cNvPr id="4" name="Picture 3" descr="ashesi_logo.png"/>
+          <p:cNvPicPr>
+            <a:picLocks noChangeAspect="1"/>
+          </p:cNvPicPr>
+          <p:nvPr/>
+        </p:nvPicPr>
+        <p:blipFill>
+          <a:blip r:embed="rId2"/>
+          <a:stretch>
+            <a:fillRect/>
+          </a:stretch>
+        </p:blipFill>
+        <p:spPr>
+          <a:xfrm>
+            <a:off x="10789920" y="320040"/>
+            <a:ext cx="886539" cy="685800"/>
+          </a:xfrm>
+          <a:prstGeom prst="rect">
+            <a:avLst/>
+          </a:prstGeom>
+        </p:spPr>
+      </p:pic>
+      <p:sp>
+        <p:nvSpPr>
+          <p:cNvPr id="5" name="TextBox 4"/>
+          <p:cNvSpPr txBox="1"/>
+          <p:nvPr/>
+        </p:nvSpPr>
+        <p:spPr>
+          <a:xfrm>
+            <a:off x="731520" y="6446520"/>
+            <a:ext cx="10728655" cy="274320"/>
+          </a:xfrm>
+          <a:prstGeom prst="rect">
+            <a:avLst/>
+          </a:prstGeom>
+          <a:noFill/>
+        </p:spPr>
+        <p:txBody>
+          <a:bodyPr wrap="none" lIns="0" tIns="0" rIns="0" bIns="0">
+            <a:spAutoFit/>
+          </a:bodyPr>
+          <a:lstStyle/>
+          <a:p>
+            <a:pPr>
+              <a:defRPr sz="900">
+                <a:solidFill>
+                  <a:srgbClr val="5A626A"/>
+                </a:solidFill>
+                <a:latin typeface="Candara"/>
+              </a:defRPr>
+            </a:pPr>
+            <a:r>
+              <a:t>Ashesi University · ICS553 Machine Learning Essentials · Group 3 · Prosit 1 Advisory Brief</a:t>
+            </a:r>
+          </a:p>
+          <a:p>
+            <a:pPr algn="r">
+              <a:defRPr sz="900">
+                <a:solidFill>
+                  <a:srgbClr val="5A626A"/>
+                </a:solidFill>
+                <a:latin typeface="Candara"/>
+              </a:defRPr>
+            </a:pPr>
+            <a:r>
+              <a:t>2</a:t>
+            </a:r>
+          </a:p>
+        </p:txBody>
+      </p:sp>
+      <p:sp>
+        <p:nvSpPr>
+          <p:cNvPr id="6" name="Rounded Rectangle 5"/>
           <p:cNvSpPr/>
           <p:nvPr/>
         </p:nvSpPr>
         <p:spPr>
           <a:xfrm>
-            <a:off x="6309360" y="1371600"/>
+            <a:off x="731520" y="1371600"/>
             <a:ext cx="5120640" cy="4846320"/>
           </a:xfrm>
           <a:prstGeom prst="roundRect">
             <a:avLst/>
           </a:prstGeom>
           <a:solidFill>
-            <a:srgbClr val="F5F7FA"/>
+            <a:srgbClr val="F8F9FA"/>
           </a:solidFill>
           <a:ln>
             <a:solidFill>
-              <a:srgbClr val="DCE0E6"/>
+              <a:srgbClr val="E2E4E8"/>
             </a:solidFill>
           </a:ln>
         </p:spPr>
@@ -4198,13 +4648,13 @@
       </p:sp>
       <p:sp>
         <p:nvSpPr>
-          <p:cNvPr id="6" name="TextBox 5"/>
+          <p:cNvPr id="7" name="TextBox 6"/>
           <p:cNvSpPr txBox="1"/>
           <p:nvPr/>
         </p:nvSpPr>
         <p:spPr>
           <a:xfrm>
-            <a:off x="6583680" y="1554480"/>
+            <a:off x="1005840" y="1554480"/>
             <a:ext cx="4572000" cy="4389120"/>
           </a:xfrm>
           <a:prstGeom prst="rect">
@@ -4219,14 +4669,15 @@
           <a:lstStyle/>
           <a:p>
             <a:pPr>
-              <a:defRPr sz="1600" b="1">
-                <a:solidFill>
-                  <a:srgbClr val="C0392B"/>
-                </a:solidFill>
-              </a:defRPr>
-            </a:pPr>
-            <a:r>
-              <a:t>Why The Naive Heuristic Fails Catastrophically</a:t>
+              <a:defRPr sz="1700" b="1">
+                <a:solidFill>
+                  <a:srgbClr val="5E1214"/>
+                </a:solidFill>
+                <a:latin typeface="Garamond"/>
+              </a:defRPr>
+            </a:pPr>
+            <a:r>
+              <a:t>Operational Mandate &amp; Constraints</a:t>
             </a:r>
           </a:p>
           <a:p>
@@ -4238,18 +4689,20 @@
             <a:r>
               <a:rPr b="1" sz="1200">
                 <a:solidFill>
-                  <a:srgbClr val="C0392B"/>
-                </a:solidFill>
+                  <a:srgbClr val="5E1214"/>
+                </a:solidFill>
+                <a:latin typeface="Candara"/>
               </a:rPr>
-              <a:t>⚠ The Clinic Access Bias:</a:t>
-            </a:r>
-            <a:r>
-              <a:rPr sz="1200">
-                <a:solidFill>
-                  <a:srgbClr val="212121"/>
-                </a:solidFill>
+              <a:t>• Strict Resource Ceiling:</a:t>
+            </a:r>
+            <a:r>
+              <a:rPr sz="1100">
+                <a:solidFill>
+                  <a:srgbClr val="1E2022"/>
+                </a:solidFill>
+                <a:latin typeface="Candara"/>
               </a:rPr>
-              <a:t> Raw cases measure clinic attendance, not infection. Rural areas with no clinics report 0 cases!</a:t>
+              <a:t> Exactly 50,000 long-lasting ITNs available for allocation.</a:t>
             </a:r>
           </a:p>
           <a:p>
@@ -4261,18 +4714,20 @@
             <a:r>
               <a:rPr b="1" sz="1200">
                 <a:solidFill>
-                  <a:srgbClr val="C0392B"/>
-                </a:solidFill>
+                  <a:srgbClr val="5E1214"/>
+                </a:solidFill>
+                <a:latin typeface="Candara"/>
               </a:rPr>
-              <a:t>⚠ The Referral Hospital Trap:</a:t>
-            </a:r>
-            <a:r>
-              <a:rPr sz="1200">
-                <a:solidFill>
-                  <a:srgbClr val="212121"/>
-                </a:solidFill>
+              <a:t>• Operational Scope:</a:t>
+            </a:r>
+            <a:r>
+              <a:rPr sz="1100">
+                <a:solidFill>
+                  <a:srgbClr val="1E2022"/>
+                </a:solidFill>
+                <a:latin typeface="Candara"/>
               </a:rPr>
-              <a:t> Regional hospitals (Bolgatanga, Wa) log thousands of cases from patients travelling from outside districts.</a:t>
+              <a:t> 50 administrative districts across Northern, Upper East, and Upper West regions.</a:t>
             </a:r>
           </a:p>
           <a:p>
@@ -4284,18 +4739,20 @@
             <a:r>
               <a:rPr b="1" sz="1200">
                 <a:solidFill>
-                  <a:srgbClr val="C0392B"/>
-                </a:solidFill>
+                  <a:srgbClr val="5E1214"/>
+                </a:solidFill>
+                <a:latin typeface="Candara"/>
               </a:rPr>
-              <a:t>⚠ Satiation &amp; Existing Coverage:</a:t>
-            </a:r>
-            <a:r>
-              <a:rPr sz="1200">
-                <a:solidFill>
-                  <a:srgbClr val="212121"/>
-                </a:solidFill>
+              <a:t>• Physical Indivisibility:</a:t>
+            </a:r>
+            <a:r>
+              <a:rPr sz="1100">
+                <a:solidFill>
+                  <a:srgbClr val="1E2022"/>
+                </a:solidFill>
+                <a:latin typeface="Candara"/>
               </a:rPr>
-              <a:t> Upper East already has 79.6% net coverage. Dumping nets there gives zero marginal benefit.</a:t>
+              <a:t> Integer allocations required (no fractional nets; resolved via Hamilton Apportionment).</a:t>
             </a:r>
           </a:p>
           <a:p>
@@ -4307,16 +4764,199 @@
             <a:r>
               <a:rPr b="1" sz="1200">
                 <a:solidFill>
-                  <a:srgbClr val="C0392B"/>
-                </a:solidFill>
+                  <a:srgbClr val="5E1214"/>
+                </a:solidFill>
+                <a:latin typeface="Candara"/>
+              </a:rPr>
+              <a:t>• Asymmetric Minimax Loss:</a:t>
+            </a:r>
+            <a:r>
+              <a:rPr sz="1100">
+                <a:solidFill>
+                  <a:srgbClr val="1E2022"/>
+                </a:solidFill>
+                <a:latin typeface="Candara"/>
+              </a:rPr>
+              <a:t> Under-allocating to an epidemic zone costs lives; over-allocating incurs only minor warehousing friction. We evaluate risk at the 95% upper bound.</a:t>
+            </a:r>
+          </a:p>
+        </p:txBody>
+      </p:sp>
+      <p:sp>
+        <p:nvSpPr>
+          <p:cNvPr id="8" name="Rounded Rectangle 7"/>
+          <p:cNvSpPr/>
+          <p:nvPr/>
+        </p:nvSpPr>
+        <p:spPr>
+          <a:xfrm>
+            <a:off x="6309360" y="1371600"/>
+            <a:ext cx="5120640" cy="4846320"/>
+          </a:xfrm>
+          <a:prstGeom prst="roundRect">
+            <a:avLst/>
+          </a:prstGeom>
+          <a:solidFill>
+            <a:srgbClr val="F8F9FA"/>
+          </a:solidFill>
+          <a:ln>
+            <a:solidFill>
+              <a:srgbClr val="E2E4E8"/>
+            </a:solidFill>
+          </a:ln>
+        </p:spPr>
+        <p:style>
+          <a:lnRef idx="1">
+            <a:schemeClr val="accent1"/>
+          </a:lnRef>
+          <a:fillRef idx="3">
+            <a:schemeClr val="accent1"/>
+          </a:fillRef>
+          <a:effectRef idx="2">
+            <a:schemeClr val="accent1"/>
+          </a:effectRef>
+          <a:fontRef idx="minor">
+            <a:schemeClr val="lt1"/>
+          </a:fontRef>
+        </p:style>
+        <p:txBody>
+          <a:bodyPr rtlCol="0" anchor="ctr"/>
+          <a:lstStyle/>
+          <a:p>
+            <a:pPr algn="ctr"/>
+          </a:p>
+        </p:txBody>
+      </p:sp>
+      <p:sp>
+        <p:nvSpPr>
+          <p:cNvPr id="9" name="TextBox 8"/>
+          <p:cNvSpPr txBox="1"/>
+          <p:nvPr/>
+        </p:nvSpPr>
+        <p:spPr>
+          <a:xfrm>
+            <a:off x="6583680" y="1554480"/>
+            <a:ext cx="4572000" cy="4389120"/>
+          </a:xfrm>
+          <a:prstGeom prst="rect">
+            <a:avLst/>
+          </a:prstGeom>
+          <a:noFill/>
+        </p:spPr>
+        <p:txBody>
+          <a:bodyPr wrap="square">
+            <a:spAutoFit/>
+          </a:bodyPr>
+          <a:lstStyle/>
+          <a:p>
+            <a:pPr>
+              <a:defRPr sz="1700" b="1">
+                <a:solidFill>
+                  <a:srgbClr val="B33939"/>
+                </a:solidFill>
+                <a:latin typeface="Garamond"/>
+              </a:defRPr>
+            </a:pPr>
+            <a:r>
+              <a:t>Why The Naive Heuristic Fails</a:t>
+            </a:r>
+          </a:p>
+          <a:p>
+            <a:pPr>
+              <a:spcBef>
+                <a:spcPts val="1200"/>
+              </a:spcBef>
+            </a:pPr>
+            <a:r>
+              <a:rPr b="1" sz="1200">
+                <a:solidFill>
+                  <a:srgbClr val="B33939"/>
+                </a:solidFill>
+                <a:latin typeface="Candara"/>
+              </a:rPr>
+              <a:t>⚠ The Clinic Access Bias:</a:t>
+            </a:r>
+            <a:r>
+              <a:rPr sz="1100">
+                <a:solidFill>
+                  <a:srgbClr val="1E2022"/>
+                </a:solidFill>
+                <a:latin typeface="Candara"/>
+              </a:rPr>
+              <a:t> Raw cases measure clinic attendance, not infection. Rural areas with no clinics report 0 cases!</a:t>
+            </a:r>
+          </a:p>
+          <a:p>
+            <a:pPr>
+              <a:spcBef>
+                <a:spcPts val="1200"/>
+              </a:spcBef>
+            </a:pPr>
+            <a:r>
+              <a:rPr b="1" sz="1200">
+                <a:solidFill>
+                  <a:srgbClr val="B33939"/>
+                </a:solidFill>
+                <a:latin typeface="Candara"/>
+              </a:rPr>
+              <a:t>⚠ The Referral Hospital Trap:</a:t>
+            </a:r>
+            <a:r>
+              <a:rPr sz="1100">
+                <a:solidFill>
+                  <a:srgbClr val="1E2022"/>
+                </a:solidFill>
+                <a:latin typeface="Candara"/>
+              </a:rPr>
+              <a:t> Regional hospitals (Bolgatanga, Wa) log thousands of cases from patients travelling from outside districts.</a:t>
+            </a:r>
+          </a:p>
+          <a:p>
+            <a:pPr>
+              <a:spcBef>
+                <a:spcPts val="1200"/>
+              </a:spcBef>
+            </a:pPr>
+            <a:r>
+              <a:rPr b="1" sz="1200">
+                <a:solidFill>
+                  <a:srgbClr val="B33939"/>
+                </a:solidFill>
+                <a:latin typeface="Candara"/>
+              </a:rPr>
+              <a:t>⚠ Satiation &amp; Diminishing Utility:</a:t>
+            </a:r>
+            <a:r>
+              <a:rPr sz="1100">
+                <a:solidFill>
+                  <a:srgbClr val="1E2022"/>
+                </a:solidFill>
+                <a:latin typeface="Candara"/>
+              </a:rPr>
+              <a:t> Upper East already has 79.6% net coverage. Dumping nets there gives zero marginal benefit.</a:t>
+            </a:r>
+          </a:p>
+          <a:p>
+            <a:pPr>
+              <a:spcBef>
+                <a:spcPts val="1200"/>
+              </a:spcBef>
+            </a:pPr>
+            <a:r>
+              <a:rPr b="1" sz="1200">
+                <a:solidFill>
+                  <a:srgbClr val="B33939"/>
+                </a:solidFill>
+                <a:latin typeface="Candara"/>
               </a:rPr>
               <a:t>⚠ Ignoring Over-dispersion:</a:t>
             </a:r>
             <a:r>
-              <a:rPr sz="1200">
-                <a:solidFill>
-                  <a:srgbClr val="212121"/>
-                </a:solidFill>
+              <a:rPr sz="1100">
+                <a:solidFill>
+                  <a:srgbClr val="1E2022"/>
+                </a:solidFill>
+                <a:latin typeface="Candara"/>
               </a:rPr>
               <a:t> High localized spikes are treated as ordinary noise, leaving high-risk zones under-protected.</a:t>
             </a:r>
@@ -4343,120 +4983,23 @@
       <p:grpSpPr/>
       <p:sp>
         <p:nvSpPr>
-          <p:cNvPr id="2" name="TextBox 1"/>
-          <p:cNvSpPr txBox="1"/>
-          <p:nvPr/>
-        </p:nvSpPr>
-        <p:spPr>
-          <a:xfrm>
-            <a:off x="731520" y="365760"/>
-            <a:ext cx="10728655" cy="822960"/>
+          <p:cNvPr id="2" name="Rectangle 1"/>
+          <p:cNvSpPr/>
+          <p:nvPr/>
+        </p:nvSpPr>
+        <p:spPr>
+          <a:xfrm>
+            <a:off x="0" y="0"/>
+            <a:ext cx="12191695" cy="73152"/>
           </a:xfrm>
           <a:prstGeom prst="rect">
             <a:avLst/>
           </a:prstGeom>
-          <a:noFill/>
-        </p:spPr>
-        <p:txBody>
-          <a:bodyPr wrap="square" lIns="0" tIns="0" rIns="0" bIns="0">
-            <a:spAutoFit/>
-          </a:bodyPr>
-          <a:lstStyle/>
-          <a:p>
-            <a:pPr>
-              <a:defRPr sz="1100" b="1">
-                <a:solidFill>
-                  <a:srgbClr val="009688"/>
-                </a:solidFill>
-              </a:defRPr>
-            </a:pPr>
-            <a:r>
-              <a:t>THEME B1 GEOSPATIAL EDA</a:t>
-            </a:r>
-          </a:p>
-          <a:p>
-            <a:pPr>
-              <a:defRPr sz="2200" b="1">
-                <a:solidFill>
-                  <a:srgbClr val="0F2043"/>
-                </a:solidFill>
-              </a:defRPr>
-            </a:pPr>
-            <a:r>
-              <a:t>Geospatial Surveillance &amp; Survey Data Divide</a:t>
-            </a:r>
-          </a:p>
-        </p:txBody>
-      </p:sp>
-      <p:pic>
-        <p:nvPicPr>
-          <p:cNvPr id="3" name="Picture 2" descr="b1_data_availability.png"/>
-          <p:cNvPicPr>
-            <a:picLocks noChangeAspect="1"/>
-          </p:cNvPicPr>
-          <p:nvPr/>
-        </p:nvPicPr>
-        <p:blipFill>
-          <a:blip r:embed="rId2"/>
-          <a:stretch>
-            <a:fillRect/>
-          </a:stretch>
-        </p:blipFill>
-        <p:spPr>
-          <a:xfrm>
-            <a:off x="731520" y="1371600"/>
-            <a:ext cx="4023360" cy="5470149"/>
-          </a:xfrm>
-          <a:prstGeom prst="rect">
-            <a:avLst/>
-          </a:prstGeom>
-        </p:spPr>
-      </p:pic>
-      <p:pic>
-        <p:nvPicPr>
-          <p:cNvPr id="4" name="Picture 3" descr="b1_district_case_rate.png"/>
-          <p:cNvPicPr>
-            <a:picLocks noChangeAspect="1"/>
-          </p:cNvPicPr>
-          <p:nvPr/>
-        </p:nvPicPr>
-        <p:blipFill>
-          <a:blip r:embed="rId3"/>
-          <a:stretch>
-            <a:fillRect/>
-          </a:stretch>
-        </p:blipFill>
-        <p:spPr>
-          <a:xfrm>
-            <a:off x="5029200" y="1371600"/>
-            <a:ext cx="4023360" cy="6010172"/>
-          </a:xfrm>
-          <a:prstGeom prst="rect">
-            <a:avLst/>
-          </a:prstGeom>
-        </p:spPr>
-      </p:pic>
-      <p:sp>
-        <p:nvSpPr>
-          <p:cNvPr id="5" name="Rounded Rectangle 4"/>
-          <p:cNvSpPr/>
-          <p:nvPr/>
-        </p:nvSpPr>
-        <p:spPr>
-          <a:xfrm>
-            <a:off x="9235440" y="1371600"/>
-            <a:ext cx="2286000" cy="4937760"/>
-          </a:xfrm>
-          <a:prstGeom prst="roundRect">
-            <a:avLst/>
-          </a:prstGeom>
           <a:solidFill>
-            <a:srgbClr val="F5F7FA"/>
+            <a:srgbClr val="A83F43"/>
           </a:solidFill>
           <a:ln>
-            <a:solidFill>
-              <a:srgbClr val="DCE0E6"/>
-            </a:solidFill>
+            <a:noFill/>
           </a:ln>
         </p:spPr>
         <p:style>
@@ -4483,14 +5026,229 @@
       </p:sp>
       <p:sp>
         <p:nvSpPr>
-          <p:cNvPr id="6" name="TextBox 5"/>
+          <p:cNvPr id="3" name="TextBox 2"/>
           <p:cNvSpPr txBox="1"/>
           <p:nvPr/>
         </p:nvSpPr>
         <p:spPr>
           <a:xfrm>
-            <a:off x="9326880" y="1554480"/>
-            <a:ext cx="2103120" cy="4572000"/>
+            <a:off x="731520" y="365760"/>
+            <a:ext cx="9144000" cy="868680"/>
+          </a:xfrm>
+          <a:prstGeom prst="rect">
+            <a:avLst/>
+          </a:prstGeom>
+          <a:noFill/>
+        </p:spPr>
+        <p:txBody>
+          <a:bodyPr wrap="square" lIns="0" tIns="0" rIns="0" bIns="0">
+            <a:spAutoFit/>
+          </a:bodyPr>
+          <a:lstStyle/>
+          <a:p>
+            <a:pPr>
+              <a:defRPr sz="1000" b="1">
+                <a:solidFill>
+                  <a:srgbClr val="A83F43"/>
+                </a:solidFill>
+                <a:latin typeface="Candara"/>
+              </a:defRPr>
+            </a:pPr>
+            <a:r>
+              <a:t>THEME B1 GEOSPATIAL EDA</a:t>
+            </a:r>
+          </a:p>
+          <a:p>
+            <a:pPr>
+              <a:defRPr sz="2300" b="1">
+                <a:solidFill>
+                  <a:srgbClr val="5E1214"/>
+                </a:solidFill>
+                <a:latin typeface="Garamond"/>
+              </a:defRPr>
+            </a:pPr>
+            <a:r>
+              <a:t>Geospatial Surveillance &amp; Survey Data Divide</a:t>
+            </a:r>
+          </a:p>
+        </p:txBody>
+      </p:sp>
+      <p:pic>
+        <p:nvPicPr>
+          <p:cNvPr id="4" name="Picture 3" descr="ashesi_logo.png"/>
+          <p:cNvPicPr>
+            <a:picLocks noChangeAspect="1"/>
+          </p:cNvPicPr>
+          <p:nvPr/>
+        </p:nvPicPr>
+        <p:blipFill>
+          <a:blip r:embed="rId2"/>
+          <a:stretch>
+            <a:fillRect/>
+          </a:stretch>
+        </p:blipFill>
+        <p:spPr>
+          <a:xfrm>
+            <a:off x="10789920" y="320040"/>
+            <a:ext cx="886539" cy="685800"/>
+          </a:xfrm>
+          <a:prstGeom prst="rect">
+            <a:avLst/>
+          </a:prstGeom>
+        </p:spPr>
+      </p:pic>
+      <p:sp>
+        <p:nvSpPr>
+          <p:cNvPr id="5" name="TextBox 4"/>
+          <p:cNvSpPr txBox="1"/>
+          <p:nvPr/>
+        </p:nvSpPr>
+        <p:spPr>
+          <a:xfrm>
+            <a:off x="731520" y="6446520"/>
+            <a:ext cx="10728655" cy="274320"/>
+          </a:xfrm>
+          <a:prstGeom prst="rect">
+            <a:avLst/>
+          </a:prstGeom>
+          <a:noFill/>
+        </p:spPr>
+        <p:txBody>
+          <a:bodyPr wrap="none" lIns="0" tIns="0" rIns="0" bIns="0">
+            <a:spAutoFit/>
+          </a:bodyPr>
+          <a:lstStyle/>
+          <a:p>
+            <a:pPr>
+              <a:defRPr sz="900">
+                <a:solidFill>
+                  <a:srgbClr val="5A626A"/>
+                </a:solidFill>
+                <a:latin typeface="Candara"/>
+              </a:defRPr>
+            </a:pPr>
+            <a:r>
+              <a:t>Ashesi University · ICS553 Machine Learning Essentials · Group 3 · Prosit 1 Advisory Brief</a:t>
+            </a:r>
+          </a:p>
+          <a:p>
+            <a:pPr algn="r">
+              <a:defRPr sz="900">
+                <a:solidFill>
+                  <a:srgbClr val="5A626A"/>
+                </a:solidFill>
+                <a:latin typeface="Candara"/>
+              </a:defRPr>
+            </a:pPr>
+            <a:r>
+              <a:t>3</a:t>
+            </a:r>
+          </a:p>
+        </p:txBody>
+      </p:sp>
+      <p:pic>
+        <p:nvPicPr>
+          <p:cNvPr id="6" name="Picture 5" descr="b1_data_availability.png"/>
+          <p:cNvPicPr>
+            <a:picLocks noChangeAspect="1"/>
+          </p:cNvPicPr>
+          <p:nvPr/>
+        </p:nvPicPr>
+        <p:blipFill>
+          <a:blip r:embed="rId3"/>
+          <a:stretch>
+            <a:fillRect/>
+          </a:stretch>
+        </p:blipFill>
+        <p:spPr>
+          <a:xfrm>
+            <a:off x="731520" y="1371600"/>
+            <a:ext cx="4023360" cy="5470149"/>
+          </a:xfrm>
+          <a:prstGeom prst="rect">
+            <a:avLst/>
+          </a:prstGeom>
+        </p:spPr>
+      </p:pic>
+      <p:pic>
+        <p:nvPicPr>
+          <p:cNvPr id="7" name="Picture 6" descr="b1_district_case_rate.png"/>
+          <p:cNvPicPr>
+            <a:picLocks noChangeAspect="1"/>
+          </p:cNvPicPr>
+          <p:nvPr/>
+        </p:nvPicPr>
+        <p:blipFill>
+          <a:blip r:embed="rId4"/>
+          <a:stretch>
+            <a:fillRect/>
+          </a:stretch>
+        </p:blipFill>
+        <p:spPr>
+          <a:xfrm>
+            <a:off x="4937760" y="1371600"/>
+            <a:ext cx="4023360" cy="6010172"/>
+          </a:xfrm>
+          <a:prstGeom prst="rect">
+            <a:avLst/>
+          </a:prstGeom>
+        </p:spPr>
+      </p:pic>
+      <p:sp>
+        <p:nvSpPr>
+          <p:cNvPr id="8" name="Rounded Rectangle 7"/>
+          <p:cNvSpPr/>
+          <p:nvPr/>
+        </p:nvSpPr>
+        <p:spPr>
+          <a:xfrm>
+            <a:off x="9144000" y="1371600"/>
+            <a:ext cx="2331720" cy="4846320"/>
+          </a:xfrm>
+          <a:prstGeom prst="roundRect">
+            <a:avLst/>
+          </a:prstGeom>
+          <a:solidFill>
+            <a:srgbClr val="F8F9FA"/>
+          </a:solidFill>
+          <a:ln>
+            <a:solidFill>
+              <a:srgbClr val="E2E4E8"/>
+            </a:solidFill>
+          </a:ln>
+        </p:spPr>
+        <p:style>
+          <a:lnRef idx="1">
+            <a:schemeClr val="accent1"/>
+          </a:lnRef>
+          <a:fillRef idx="3">
+            <a:schemeClr val="accent1"/>
+          </a:fillRef>
+          <a:effectRef idx="2">
+            <a:schemeClr val="accent1"/>
+          </a:effectRef>
+          <a:fontRef idx="minor">
+            <a:schemeClr val="lt1"/>
+          </a:fontRef>
+        </p:style>
+        <p:txBody>
+          <a:bodyPr rtlCol="0" anchor="ctr"/>
+          <a:lstStyle/>
+          <a:p>
+            <a:pPr algn="ctr"/>
+          </a:p>
+        </p:txBody>
+      </p:sp>
+      <p:sp>
+        <p:nvSpPr>
+          <p:cNvPr id="9" name="TextBox 8"/>
+          <p:cNvSpPr txBox="1"/>
+          <p:nvPr/>
+        </p:nvSpPr>
+        <p:spPr>
+          <a:xfrm>
+            <a:off x="9281160" y="1554480"/>
+            <a:ext cx="2057400" cy="4480560"/>
           </a:xfrm>
           <a:prstGeom prst="rect">
             <a:avLst/>
@@ -4504,14 +5262,15 @@
           <a:lstStyle/>
           <a:p>
             <a:pPr>
-              <a:defRPr sz="1300" b="1">
-                <a:solidFill>
-                  <a:srgbClr val="0F2043"/>
-                </a:solidFill>
-              </a:defRPr>
-            </a:pPr>
-            <a:r>
-              <a:t>Key Cartographic Findings</a:t>
+              <a:defRPr sz="1400" b="1">
+                <a:solidFill>
+                  <a:srgbClr val="5E1214"/>
+                </a:solidFill>
+                <a:latin typeface="Garamond"/>
+              </a:defRPr>
+            </a:pPr>
+            <a:r>
+              <a:t>Cartographic Insights</a:t>
             </a:r>
           </a:p>
           <a:p>
@@ -4521,8 +5280,9 @@
               </a:spcBef>
               <a:defRPr sz="1000">
                 <a:solidFill>
-                  <a:srgbClr val="212121"/>
-                </a:solidFill>
+                  <a:srgbClr val="1E2022"/>
+                </a:solidFill>
+                <a:latin typeface="Candara"/>
               </a:defRPr>
             </a:pPr>
             <a:r>
@@ -4536,12 +5296,13 @@
               </a:spcBef>
               <a:defRPr sz="1000">
                 <a:solidFill>
-                  <a:srgbClr val="212121"/>
-                </a:solidFill>
-              </a:defRPr>
-            </a:pPr>
-            <a:r>
-              <a:t>2. Survey Density: DHS 2022 sampled 618 clusters nationwide, but Northern Region rural clusters carry wide sampling errors.</a:t>
+                  <a:srgbClr val="1E2022"/>
+                </a:solidFill>
+                <a:latin typeface="Candara"/>
+              </a:defRPr>
+            </a:pPr>
+            <a:r>
+              <a:t>2. Survey Density: DHS 2022 sampled 618 clusters nationwide, but rural northern clusters carry wide sampling errors.</a:t>
             </a:r>
           </a:p>
           <a:p>
@@ -4551,12 +5312,13 @@
               </a:spcBef>
               <a:defRPr sz="1000">
                 <a:solidFill>
-                  <a:srgbClr val="212121"/>
-                </a:solidFill>
-              </a:defRPr>
-            </a:pPr>
-            <a:r>
-              <a:t>3. Survey Weighting Effect: Unweighted net ownership (70.96%) overstates true weighted ownership (66.77%) by 4.19 percentage points.</a:t>
+                  <a:srgbClr val="1E2022"/>
+                </a:solidFill>
+                <a:latin typeface="Candara"/>
+              </a:defRPr>
+            </a:pPr>
+            <a:r>
+              <a:t>3. Survey Weighting: Unweighted net ownership (70.96%) overstates true weighted ownership (66.77%) by 4.19 percentage points.</a:t>
             </a:r>
           </a:p>
         </p:txBody>
@@ -4581,72 +5343,23 @@
       <p:grpSpPr/>
       <p:sp>
         <p:nvSpPr>
-          <p:cNvPr id="2" name="TextBox 1"/>
-          <p:cNvSpPr txBox="1"/>
-          <p:nvPr/>
-        </p:nvSpPr>
-        <p:spPr>
-          <a:xfrm>
-            <a:off x="731520" y="365760"/>
-            <a:ext cx="10728655" cy="822960"/>
+          <p:cNvPr id="2" name="Rectangle 1"/>
+          <p:cNvSpPr/>
+          <p:nvPr/>
+        </p:nvSpPr>
+        <p:spPr>
+          <a:xfrm>
+            <a:off x="0" y="0"/>
+            <a:ext cx="12191695" cy="73152"/>
           </a:xfrm>
           <a:prstGeom prst="rect">
             <a:avLst/>
           </a:prstGeom>
-          <a:noFill/>
-        </p:spPr>
-        <p:txBody>
-          <a:bodyPr wrap="square" lIns="0" tIns="0" rIns="0" bIns="0">
-            <a:spAutoFit/>
-          </a:bodyPr>
-          <a:lstStyle/>
-          <a:p>
-            <a:pPr>
-              <a:defRPr sz="1100" b="1">
-                <a:solidFill>
-                  <a:srgbClr val="009688"/>
-                </a:solidFill>
-              </a:defRPr>
-            </a:pPr>
-            <a:r>
-              <a:t>THEME A STATISTICAL MODELING</a:t>
-            </a:r>
-          </a:p>
-          <a:p>
-            <a:pPr>
-              <a:defRPr sz="2200" b="1">
-                <a:solidFill>
-                  <a:srgbClr val="0F2043"/>
-                </a:solidFill>
-              </a:defRPr>
-            </a:pPr>
-            <a:r>
-              <a:t>Over-Dispersion: Why Poisson Regression Crashed</a:t>
-            </a:r>
-          </a:p>
-        </p:txBody>
-      </p:sp>
-      <p:sp>
-        <p:nvSpPr>
-          <p:cNvPr id="3" name="Rounded Rectangle 2"/>
-          <p:cNvSpPr/>
-          <p:nvPr/>
-        </p:nvSpPr>
-        <p:spPr>
-          <a:xfrm>
-            <a:off x="731520" y="1371600"/>
-            <a:ext cx="5029200" cy="4846320"/>
-          </a:xfrm>
-          <a:prstGeom prst="roundRect">
-            <a:avLst/>
-          </a:prstGeom>
           <a:solidFill>
-            <a:srgbClr val="F5F7FA"/>
+            <a:srgbClr val="A83F43"/>
           </a:solidFill>
           <a:ln>
-            <a:solidFill>
-              <a:srgbClr val="DCE0E6"/>
-            </a:solidFill>
+            <a:noFill/>
           </a:ln>
         </p:spPr>
         <p:style>
@@ -4673,7 +5386,174 @@
       </p:sp>
       <p:sp>
         <p:nvSpPr>
-          <p:cNvPr id="4" name="TextBox 3"/>
+          <p:cNvPr id="3" name="TextBox 2"/>
+          <p:cNvSpPr txBox="1"/>
+          <p:nvPr/>
+        </p:nvSpPr>
+        <p:spPr>
+          <a:xfrm>
+            <a:off x="731520" y="365760"/>
+            <a:ext cx="9144000" cy="868680"/>
+          </a:xfrm>
+          <a:prstGeom prst="rect">
+            <a:avLst/>
+          </a:prstGeom>
+          <a:noFill/>
+        </p:spPr>
+        <p:txBody>
+          <a:bodyPr wrap="square" lIns="0" tIns="0" rIns="0" bIns="0">
+            <a:spAutoFit/>
+          </a:bodyPr>
+          <a:lstStyle/>
+          <a:p>
+            <a:pPr>
+              <a:defRPr sz="1000" b="1">
+                <a:solidFill>
+                  <a:srgbClr val="A83F43"/>
+                </a:solidFill>
+                <a:latin typeface="Candara"/>
+              </a:defRPr>
+            </a:pPr>
+            <a:r>
+              <a:t>THEME A STATISTICAL MODELING</a:t>
+            </a:r>
+          </a:p>
+          <a:p>
+            <a:pPr>
+              <a:defRPr sz="2300" b="1">
+                <a:solidFill>
+                  <a:srgbClr val="5E1214"/>
+                </a:solidFill>
+                <a:latin typeface="Garamond"/>
+              </a:defRPr>
+            </a:pPr>
+            <a:r>
+              <a:t>Over-Dispersion: Why Poisson Regression Crashed</a:t>
+            </a:r>
+          </a:p>
+        </p:txBody>
+      </p:sp>
+      <p:pic>
+        <p:nvPicPr>
+          <p:cNvPr id="4" name="Picture 3" descr="ashesi_logo.png"/>
+          <p:cNvPicPr>
+            <a:picLocks noChangeAspect="1"/>
+          </p:cNvPicPr>
+          <p:nvPr/>
+        </p:nvPicPr>
+        <p:blipFill>
+          <a:blip r:embed="rId2"/>
+          <a:stretch>
+            <a:fillRect/>
+          </a:stretch>
+        </p:blipFill>
+        <p:spPr>
+          <a:xfrm>
+            <a:off x="10789920" y="320040"/>
+            <a:ext cx="886539" cy="685800"/>
+          </a:xfrm>
+          <a:prstGeom prst="rect">
+            <a:avLst/>
+          </a:prstGeom>
+        </p:spPr>
+      </p:pic>
+      <p:sp>
+        <p:nvSpPr>
+          <p:cNvPr id="5" name="TextBox 4"/>
+          <p:cNvSpPr txBox="1"/>
+          <p:nvPr/>
+        </p:nvSpPr>
+        <p:spPr>
+          <a:xfrm>
+            <a:off x="731520" y="6446520"/>
+            <a:ext cx="10728655" cy="274320"/>
+          </a:xfrm>
+          <a:prstGeom prst="rect">
+            <a:avLst/>
+          </a:prstGeom>
+          <a:noFill/>
+        </p:spPr>
+        <p:txBody>
+          <a:bodyPr wrap="none" lIns="0" tIns="0" rIns="0" bIns="0">
+            <a:spAutoFit/>
+          </a:bodyPr>
+          <a:lstStyle/>
+          <a:p>
+            <a:pPr>
+              <a:defRPr sz="900">
+                <a:solidFill>
+                  <a:srgbClr val="5A626A"/>
+                </a:solidFill>
+                <a:latin typeface="Candara"/>
+              </a:defRPr>
+            </a:pPr>
+            <a:r>
+              <a:t>Ashesi University · ICS553 Machine Learning Essentials · Group 3 · Prosit 1 Advisory Brief</a:t>
+            </a:r>
+          </a:p>
+          <a:p>
+            <a:pPr algn="r">
+              <a:defRPr sz="900">
+                <a:solidFill>
+                  <a:srgbClr val="5A626A"/>
+                </a:solidFill>
+                <a:latin typeface="Candara"/>
+              </a:defRPr>
+            </a:pPr>
+            <a:r>
+              <a:t>4</a:t>
+            </a:r>
+          </a:p>
+        </p:txBody>
+      </p:sp>
+      <p:sp>
+        <p:nvSpPr>
+          <p:cNvPr id="6" name="Rounded Rectangle 5"/>
+          <p:cNvSpPr/>
+          <p:nvPr/>
+        </p:nvSpPr>
+        <p:spPr>
+          <a:xfrm>
+            <a:off x="731520" y="1371600"/>
+            <a:ext cx="5029200" cy="4846320"/>
+          </a:xfrm>
+          <a:prstGeom prst="roundRect">
+            <a:avLst/>
+          </a:prstGeom>
+          <a:solidFill>
+            <a:srgbClr val="F8F9FA"/>
+          </a:solidFill>
+          <a:ln>
+            <a:solidFill>
+              <a:srgbClr val="E2E4E8"/>
+            </a:solidFill>
+          </a:ln>
+        </p:spPr>
+        <p:style>
+          <a:lnRef idx="1">
+            <a:schemeClr val="accent1"/>
+          </a:lnRef>
+          <a:fillRef idx="3">
+            <a:schemeClr val="accent1"/>
+          </a:fillRef>
+          <a:effectRef idx="2">
+            <a:schemeClr val="accent1"/>
+          </a:effectRef>
+          <a:fontRef idx="minor">
+            <a:schemeClr val="lt1"/>
+          </a:fontRef>
+        </p:style>
+        <p:txBody>
+          <a:bodyPr rtlCol="0" anchor="ctr"/>
+          <a:lstStyle/>
+          <a:p>
+            <a:pPr algn="ctr"/>
+          </a:p>
+        </p:txBody>
+      </p:sp>
+      <p:sp>
+        <p:nvSpPr>
+          <p:cNvPr id="7" name="TextBox 6"/>
           <p:cNvSpPr txBox="1"/>
           <p:nvPr/>
         </p:nvSpPr>
@@ -4694,14 +5574,15 @@
           <a:lstStyle/>
           <a:p>
             <a:pPr>
-              <a:defRPr sz="1600" b="1">
-                <a:solidFill>
-                  <a:srgbClr val="0F2043"/>
-                </a:solidFill>
-              </a:defRPr>
-            </a:pPr>
-            <a:r>
-              <a:t>The Mathematical Breakdown</a:t>
+              <a:defRPr sz="1700" b="1">
+                <a:solidFill>
+                  <a:srgbClr val="5E1214"/>
+                </a:solidFill>
+                <a:latin typeface="Garamond"/>
+              </a:defRPr>
+            </a:pPr>
+            <a:r>
+              <a:t>Mathematical Proof of Poisson Failure</a:t>
             </a:r>
           </a:p>
           <a:p>
@@ -4713,18 +5594,20 @@
             <a:r>
               <a:rPr b="1" sz="1200">
                 <a:solidFill>
-                  <a:srgbClr val="0F2043"/>
-                </a:solidFill>
+                  <a:srgbClr val="A83F43"/>
+                </a:solidFill>
+                <a:latin typeface="Candara"/>
               </a:rPr>
-              <a:t>The Poisson Assumption:</a:t>
+              <a:t>The Equidispersion Assumption:</a:t>
             </a:r>
             <a:r>
               <a:rPr sz="1100">
                 <a:solidFill>
-                  <a:srgbClr val="212121"/>
-                </a:solidFill>
+                  <a:srgbClr val="1E2022"/>
+                </a:solidFill>
+                <a:latin typeface="Candara"/>
               </a:rPr>
-              <a:t> Assumes Variance = Mean. Expected variance/mean ratio is strictly 1.0.</a:t>
+              <a:t> Poisson requires Variance = Mean (Ratio = 1.0).</a:t>
             </a:r>
           </a:p>
           <a:p>
@@ -4736,18 +5619,20 @@
             <a:r>
               <a:rPr b="1" sz="1200">
                 <a:solidFill>
-                  <a:srgbClr val="0F2043"/>
-                </a:solidFill>
+                  <a:srgbClr val="A83F43"/>
+                </a:solidFill>
+                <a:latin typeface="Candara"/>
               </a:rPr>
-              <a:t>Observed Reality:</a:t>
+              <a:t>Extreme Real-World Dispersion:</a:t>
             </a:r>
             <a:r>
               <a:rPr sz="1100">
                 <a:solidFill>
-                  <a:srgbClr val="212121"/>
-                </a:solidFill>
+                  <a:srgbClr val="1E2022"/>
+                </a:solidFill>
+                <a:latin typeface="Candara"/>
               </a:rPr>
-              <a:t> In northern Ghana, Variance / Mean = 77,183! Observed SD is 122,882 vs Poisson SD of 442 (278x narrower).</a:t>
+              <a:t> In northern Ghana, Variance / Mean = 77,183! Observed SD is 122,882 vs Poisson SD of 442 (278x too narrow!).</a:t>
             </a:r>
           </a:p>
           <a:p>
@@ -4759,16 +5644,18 @@
             <a:r>
               <a:rPr b="1" sz="1200">
                 <a:solidFill>
-                  <a:srgbClr val="0F2043"/>
-                </a:solidFill>
+                  <a:srgbClr val="A83F43"/>
+                </a:solidFill>
+                <a:latin typeface="Candara"/>
               </a:rPr>
               <a:t>Survives Population Offset:</a:t>
             </a:r>
             <a:r>
               <a:rPr sz="1100">
                 <a:solidFill>
-                  <a:srgbClr val="212121"/>
-                </a:solidFill>
+                  <a:srgbClr val="1E2022"/>
+                </a:solidFill>
+                <a:latin typeface="Candara"/>
               </a:rPr>
               <a:t> Pearson chi2/df = 54,147. Poisson fails catastrophically even after adjusting for district population.</a:t>
             </a:r>
@@ -4782,32 +5669,34 @@
             <a:r>
               <a:rPr b="1" sz="1200">
                 <a:solidFill>
-                  <a:srgbClr val="0F2043"/>
-                </a:solidFill>
+                  <a:srgbClr val="A83F43"/>
+                </a:solidFill>
+                <a:latin typeface="Candara"/>
               </a:rPr>
               <a:t>Negative Binomial (NB2):</a:t>
             </a:r>
             <a:r>
               <a:rPr sz="1100">
                 <a:solidFill>
-                  <a:srgbClr val="212121"/>
-                </a:solidFill>
+                  <a:srgbClr val="1E2022"/>
+                </a:solidFill>
+                <a:latin typeface="Candara"/>
               </a:rPr>
-              <a:t> Adds dispersion knob (alpha = 0.2677), allowing Var = mu + alpha*mu^2. Outperforms Poisson by 2,393,669 AIC points!</a:t>
+              <a:t> Adds dispersion parameter (alpha = 0.2677), allowing Var = mu + alpha*mu^2. Beats Poisson by 2,393,669 AIC points!</a:t>
             </a:r>
           </a:p>
         </p:txBody>
       </p:sp>
       <p:pic>
         <p:nvPicPr>
-          <p:cNvPr id="5" name="Picture 4" descr="a3_poisson_vs_nb.png"/>
+          <p:cNvPr id="8" name="Picture 7" descr="a3_poisson_vs_nb.png"/>
           <p:cNvPicPr>
             <a:picLocks noChangeAspect="1"/>
           </p:cNvPicPr>
           <p:nvPr/>
         </p:nvPicPr>
         <p:blipFill>
-          <a:blip r:embed="rId2"/>
+          <a:blip r:embed="rId3"/>
           <a:stretch>
             <a:fillRect/>
           </a:stretch>
@@ -4842,72 +5731,23 @@
       <p:grpSpPr/>
       <p:sp>
         <p:nvSpPr>
-          <p:cNvPr id="2" name="TextBox 1"/>
-          <p:cNvSpPr txBox="1"/>
-          <p:nvPr/>
-        </p:nvSpPr>
-        <p:spPr>
-          <a:xfrm>
-            <a:off x="731520" y="365760"/>
-            <a:ext cx="10728655" cy="822960"/>
+          <p:cNvPr id="2" name="Rectangle 1"/>
+          <p:cNvSpPr/>
+          <p:nvPr/>
+        </p:nvSpPr>
+        <p:spPr>
+          <a:xfrm>
+            <a:off x="0" y="0"/>
+            <a:ext cx="12191695" cy="73152"/>
           </a:xfrm>
           <a:prstGeom prst="rect">
             <a:avLst/>
           </a:prstGeom>
-          <a:noFill/>
-        </p:spPr>
-        <p:txBody>
-          <a:bodyPr wrap="square" lIns="0" tIns="0" rIns="0" bIns="0">
-            <a:spAutoFit/>
-          </a:bodyPr>
-          <a:lstStyle/>
-          <a:p>
-            <a:pPr>
-              <a:defRPr sz="1100" b="1">
-                <a:solidFill>
-                  <a:srgbClr val="009688"/>
-                </a:solidFill>
-              </a:defRPr>
-            </a:pPr>
-            <a:r>
-              <a:t>THEME A SAMPLING THEORY</a:t>
-            </a:r>
-          </a:p>
-          <a:p>
-            <a:pPr>
-              <a:defRPr sz="2200" b="1">
-                <a:solidFill>
-                  <a:srgbClr val="0F2043"/>
-                </a:solidFill>
-              </a:defRPr>
-            </a:pPr>
-            <a:r>
-              <a:t>Honest Uncertainty: The Two-Stage Cluster Bootstrap</a:t>
-            </a:r>
-          </a:p>
-        </p:txBody>
-      </p:sp>
-      <p:sp>
-        <p:nvSpPr>
-          <p:cNvPr id="3" name="Rounded Rectangle 2"/>
-          <p:cNvSpPr/>
-          <p:nvPr/>
-        </p:nvSpPr>
-        <p:spPr>
-          <a:xfrm>
-            <a:off x="731520" y="1371600"/>
-            <a:ext cx="5029200" cy="4846320"/>
-          </a:xfrm>
-          <a:prstGeom prst="roundRect">
-            <a:avLst/>
-          </a:prstGeom>
           <a:solidFill>
-            <a:srgbClr val="F5F7FA"/>
+            <a:srgbClr val="A83F43"/>
           </a:solidFill>
           <a:ln>
-            <a:solidFill>
-              <a:srgbClr val="DCE0E6"/>
-            </a:solidFill>
+            <a:noFill/>
           </a:ln>
         </p:spPr>
         <p:style>
@@ -4934,7 +5774,174 @@
       </p:sp>
       <p:sp>
         <p:nvSpPr>
-          <p:cNvPr id="4" name="TextBox 3"/>
+          <p:cNvPr id="3" name="TextBox 2"/>
+          <p:cNvSpPr txBox="1"/>
+          <p:nvPr/>
+        </p:nvSpPr>
+        <p:spPr>
+          <a:xfrm>
+            <a:off x="731520" y="365760"/>
+            <a:ext cx="9144000" cy="868680"/>
+          </a:xfrm>
+          <a:prstGeom prst="rect">
+            <a:avLst/>
+          </a:prstGeom>
+          <a:noFill/>
+        </p:spPr>
+        <p:txBody>
+          <a:bodyPr wrap="square" lIns="0" tIns="0" rIns="0" bIns="0">
+            <a:spAutoFit/>
+          </a:bodyPr>
+          <a:lstStyle/>
+          <a:p>
+            <a:pPr>
+              <a:defRPr sz="1000" b="1">
+                <a:solidFill>
+                  <a:srgbClr val="A83F43"/>
+                </a:solidFill>
+                <a:latin typeface="Candara"/>
+              </a:defRPr>
+            </a:pPr>
+            <a:r>
+              <a:t>THEME A SAMPLING THEORY</a:t>
+            </a:r>
+          </a:p>
+          <a:p>
+            <a:pPr>
+              <a:defRPr sz="2300" b="1">
+                <a:solidFill>
+                  <a:srgbClr val="5E1214"/>
+                </a:solidFill>
+                <a:latin typeface="Garamond"/>
+              </a:defRPr>
+            </a:pPr>
+            <a:r>
+              <a:t>Honest Uncertainty: The Two-Stage Cluster Bootstrap</a:t>
+            </a:r>
+          </a:p>
+        </p:txBody>
+      </p:sp>
+      <p:pic>
+        <p:nvPicPr>
+          <p:cNvPr id="4" name="Picture 3" descr="ashesi_logo.png"/>
+          <p:cNvPicPr>
+            <a:picLocks noChangeAspect="1"/>
+          </p:cNvPicPr>
+          <p:nvPr/>
+        </p:nvPicPr>
+        <p:blipFill>
+          <a:blip r:embed="rId2"/>
+          <a:stretch>
+            <a:fillRect/>
+          </a:stretch>
+        </p:blipFill>
+        <p:spPr>
+          <a:xfrm>
+            <a:off x="10789920" y="320040"/>
+            <a:ext cx="886539" cy="685800"/>
+          </a:xfrm>
+          <a:prstGeom prst="rect">
+            <a:avLst/>
+          </a:prstGeom>
+        </p:spPr>
+      </p:pic>
+      <p:sp>
+        <p:nvSpPr>
+          <p:cNvPr id="5" name="TextBox 4"/>
+          <p:cNvSpPr txBox="1"/>
+          <p:nvPr/>
+        </p:nvSpPr>
+        <p:spPr>
+          <a:xfrm>
+            <a:off x="731520" y="6446520"/>
+            <a:ext cx="10728655" cy="274320"/>
+          </a:xfrm>
+          <a:prstGeom prst="rect">
+            <a:avLst/>
+          </a:prstGeom>
+          <a:noFill/>
+        </p:spPr>
+        <p:txBody>
+          <a:bodyPr wrap="none" lIns="0" tIns="0" rIns="0" bIns="0">
+            <a:spAutoFit/>
+          </a:bodyPr>
+          <a:lstStyle/>
+          <a:p>
+            <a:pPr>
+              <a:defRPr sz="900">
+                <a:solidFill>
+                  <a:srgbClr val="5A626A"/>
+                </a:solidFill>
+                <a:latin typeface="Candara"/>
+              </a:defRPr>
+            </a:pPr>
+            <a:r>
+              <a:t>Ashesi University · ICS553 Machine Learning Essentials · Group 3 · Prosit 1 Advisory Brief</a:t>
+            </a:r>
+          </a:p>
+          <a:p>
+            <a:pPr algn="r">
+              <a:defRPr sz="900">
+                <a:solidFill>
+                  <a:srgbClr val="5A626A"/>
+                </a:solidFill>
+                <a:latin typeface="Candara"/>
+              </a:defRPr>
+            </a:pPr>
+            <a:r>
+              <a:t>5</a:t>
+            </a:r>
+          </a:p>
+        </p:txBody>
+      </p:sp>
+      <p:sp>
+        <p:nvSpPr>
+          <p:cNvPr id="6" name="Rounded Rectangle 5"/>
+          <p:cNvSpPr/>
+          <p:nvPr/>
+        </p:nvSpPr>
+        <p:spPr>
+          <a:xfrm>
+            <a:off x="731520" y="1371600"/>
+            <a:ext cx="5029200" cy="4846320"/>
+          </a:xfrm>
+          <a:prstGeom prst="roundRect">
+            <a:avLst/>
+          </a:prstGeom>
+          <a:solidFill>
+            <a:srgbClr val="F8F9FA"/>
+          </a:solidFill>
+          <a:ln>
+            <a:solidFill>
+              <a:srgbClr val="E2E4E8"/>
+            </a:solidFill>
+          </a:ln>
+        </p:spPr>
+        <p:style>
+          <a:lnRef idx="1">
+            <a:schemeClr val="accent1"/>
+          </a:lnRef>
+          <a:fillRef idx="3">
+            <a:schemeClr val="accent1"/>
+          </a:fillRef>
+          <a:effectRef idx="2">
+            <a:schemeClr val="accent1"/>
+          </a:effectRef>
+          <a:fontRef idx="minor">
+            <a:schemeClr val="lt1"/>
+          </a:fontRef>
+        </p:style>
+        <p:txBody>
+          <a:bodyPr rtlCol="0" anchor="ctr"/>
+          <a:lstStyle/>
+          <a:p>
+            <a:pPr algn="ctr"/>
+          </a:p>
+        </p:txBody>
+      </p:sp>
+      <p:sp>
+        <p:nvSpPr>
+          <p:cNvPr id="7" name="TextBox 6"/>
           <p:cNvSpPr txBox="1"/>
           <p:nvPr/>
         </p:nvSpPr>
@@ -4955,14 +5962,15 @@
           <a:lstStyle/>
           <a:p>
             <a:pPr>
-              <a:defRPr sz="1600" b="1">
-                <a:solidFill>
-                  <a:srgbClr val="0F2043"/>
-                </a:solidFill>
-              </a:defRPr>
-            </a:pPr>
-            <a:r>
-              <a:t>Cluster Autocorrelation vs. Naive Sampling</a:t>
+              <a:defRPr sz="1700" b="1">
+                <a:solidFill>
+                  <a:srgbClr val="5E1214"/>
+                </a:solidFill>
+                <a:latin typeface="Garamond"/>
+              </a:defRPr>
+            </a:pPr>
+            <a:r>
+              <a:t>Survey Design Effects &amp; False Precision</a:t>
             </a:r>
           </a:p>
           <a:p>
@@ -4974,18 +5982,20 @@
             <a:r>
               <a:rPr b="1" sz="1200">
                 <a:solidFill>
-                  <a:srgbClr val="0F2043"/>
-                </a:solidFill>
+                  <a:srgbClr val="A83F43"/>
+                </a:solidFill>
+                <a:latin typeface="Candara"/>
               </a:rPr>
-              <a:t>The DHS Sampling Design:</a:t>
+              <a:t>Two-Stage Sampling Structure:</a:t>
             </a:r>
             <a:r>
               <a:rPr sz="1100">
                 <a:solidFill>
-                  <a:srgbClr val="212121"/>
-                </a:solidFill>
+                  <a:srgbClr val="1E2022"/>
+                </a:solidFill>
+                <a:latin typeface="Candara"/>
               </a:rPr>
-              <a:t> 2-stage cluster sampling: clusters (villages) chosen first, then 25-30 households per cluster.</a:t>
+              <a:t> DHS samples clusters (villages) first, then 25-30 households per cluster.</a:t>
             </a:r>
           </a:p>
           <a:p>
@@ -4997,18 +6007,20 @@
             <a:r>
               <a:rPr b="1" sz="1200">
                 <a:solidFill>
-                  <a:srgbClr val="0F2043"/>
-                </a:solidFill>
+                  <a:srgbClr val="A83F43"/>
+                </a:solidFill>
+                <a:latin typeface="Candara"/>
               </a:rPr>
               <a:t>Intra-Cluster Correlation:</a:t>
             </a:r>
             <a:r>
               <a:rPr sz="1100">
                 <a:solidFill>
-                  <a:srgbClr val="212121"/>
-                </a:solidFill>
+                  <a:srgbClr val="1E2022"/>
+                </a:solidFill>
+                <a:latin typeface="Candara"/>
               </a:rPr>
-              <a:t> Families in the same village share the same swamp and risk. They are NOT independent.</a:t>
+              <a:t> Families in the same village share the same standing water and risk. They are NOT independent.</a:t>
             </a:r>
           </a:p>
           <a:p>
@@ -5020,18 +6032,20 @@
             <a:r>
               <a:rPr b="1" sz="1200">
                 <a:solidFill>
-                  <a:srgbClr val="0F2043"/>
-                </a:solidFill>
+                  <a:srgbClr val="A83F43"/>
+                </a:solidFill>
+                <a:latin typeface="Candara"/>
               </a:rPr>
-              <a:t>The Naive Bootstrap Danger:</a:t>
+              <a:t>Naive Bootstrap Danger:</a:t>
             </a:r>
             <a:r>
               <a:rPr sz="1100">
                 <a:solidFill>
-                  <a:srgbClr val="212121"/>
-                </a:solidFill>
+                  <a:srgbClr val="1E2022"/>
+                </a:solidFill>
+                <a:latin typeface="Candara"/>
               </a:rPr>
-              <a:t> Resampling households ignores village clustering, giving a confidence interval of 7.17 pp (false precision!).</a:t>
+              <a:t> Resampling households independently pretends you have 17,933 independent facts, shrinking CI to 7.17 pp (false precision!).</a:t>
             </a:r>
           </a:p>
           <a:p>
@@ -5043,18 +6057,20 @@
             <a:r>
               <a:rPr b="1" sz="1200">
                 <a:solidFill>
-                  <a:srgbClr val="0F2043"/>
-                </a:solidFill>
+                  <a:srgbClr val="A83F43"/>
+                </a:solidFill>
+                <a:latin typeface="Candara"/>
               </a:rPr>
-              <a:t>The Honest Cluster Bootstrap:</a:t>
+              <a:t>Honest Cluster Bootstrap:</a:t>
             </a:r>
             <a:r>
               <a:rPr sz="1100">
                 <a:solidFill>
-                  <a:srgbClr val="212121"/>
-                </a:solidFill>
+                  <a:srgbClr val="1E2022"/>
+                </a:solidFill>
+                <a:latin typeface="Candara"/>
               </a:rPr>
-              <a:t> Resampling clusters first yields a 15.20 pp interval — 2.12x wider (DEFF = 4.50)!</a:t>
+              <a:t> Resampling clusters first gives a 15.20 pp interval — 2.12x wider (DEFF = 4.50)!</a:t>
             </a:r>
           </a:p>
           <a:p>
@@ -5066,16 +6082,18 @@
             <a:r>
               <a:rPr b="1" sz="1200">
                 <a:solidFill>
-                  <a:srgbClr val="0F2043"/>
-                </a:solidFill>
+                  <a:srgbClr val="A83F43"/>
+                </a:solidFill>
+                <a:latin typeface="Candara"/>
               </a:rPr>
               <a:t>Validation Benchmark:</a:t>
             </a:r>
             <a:r>
               <a:rPr sz="1100">
                 <a:solidFill>
-                  <a:srgbClr val="212121"/>
-                </a:solidFill>
+                  <a:srgbClr val="1E2022"/>
+                </a:solidFill>
+                <a:latin typeface="Candara"/>
               </a:rPr>
               <a:t> Survey-weighted net ownership reproduces published 2022 DHS report to 0.09 pp (67.69% vs 67.60%).</a:t>
             </a:r>
@@ -5084,14 +6102,14 @@
       </p:sp>
       <p:pic>
         <p:nvPicPr>
-          <p:cNvPr id="5" name="Picture 4" descr="a4_bootstrap_ci_comparison.png"/>
+          <p:cNvPr id="8" name="Picture 7" descr="a4_bootstrap_ci_comparison.png"/>
           <p:cNvPicPr>
             <a:picLocks noChangeAspect="1"/>
           </p:cNvPicPr>
           <p:nvPr/>
         </p:nvPicPr>
         <p:blipFill>
-          <a:blip r:embed="rId2"/>
+          <a:blip r:embed="rId3"/>
           <a:stretch>
             <a:fillRect/>
           </a:stretch>
@@ -5126,72 +6144,23 @@
       <p:grpSpPr/>
       <p:sp>
         <p:nvSpPr>
-          <p:cNvPr id="2" name="TextBox 1"/>
-          <p:cNvSpPr txBox="1"/>
-          <p:nvPr/>
-        </p:nvSpPr>
-        <p:spPr>
-          <a:xfrm>
-            <a:off x="731520" y="365760"/>
-            <a:ext cx="10728655" cy="822960"/>
+          <p:cNvPr id="2" name="Rectangle 1"/>
+          <p:cNvSpPr/>
+          <p:nvPr/>
+        </p:nvSpPr>
+        <p:spPr>
+          <a:xfrm>
+            <a:off x="0" y="0"/>
+            <a:ext cx="12191695" cy="73152"/>
           </a:xfrm>
           <a:prstGeom prst="rect">
             <a:avLst/>
           </a:prstGeom>
-          <a:noFill/>
-        </p:spPr>
-        <p:txBody>
-          <a:bodyPr wrap="square" lIns="0" tIns="0" rIns="0" bIns="0">
-            <a:spAutoFit/>
-          </a:bodyPr>
-          <a:lstStyle/>
-          <a:p>
-            <a:pPr>
-              <a:defRPr sz="1100" b="1">
-                <a:solidFill>
-                  <a:srgbClr val="009688"/>
-                </a:solidFill>
-              </a:defRPr>
-            </a:pPr>
-            <a:r>
-              <a:t>THEME B PIPELINE ENGINEERING</a:t>
-            </a:r>
-          </a:p>
-          <a:p>
-            <a:pPr>
-              <a:defRPr sz="2200" b="1">
-                <a:solidFill>
-                  <a:srgbClr val="0F2043"/>
-                </a:solidFill>
-              </a:defRPr>
-            </a:pPr>
-            <a:r>
-              <a:t>Pipeline Discipline &amp; Leakage Audit</a:t>
-            </a:r>
-          </a:p>
-        </p:txBody>
-      </p:sp>
-      <p:sp>
-        <p:nvSpPr>
-          <p:cNvPr id="3" name="Rounded Rectangle 2"/>
-          <p:cNvSpPr/>
-          <p:nvPr/>
-        </p:nvSpPr>
-        <p:spPr>
-          <a:xfrm>
-            <a:off x="731520" y="1463040"/>
-            <a:ext cx="3383280" cy="4663440"/>
-          </a:xfrm>
-          <a:prstGeom prst="roundRect">
-            <a:avLst/>
-          </a:prstGeom>
           <a:solidFill>
-            <a:srgbClr val="F5F7FA"/>
+            <a:srgbClr val="A83F43"/>
           </a:solidFill>
           <a:ln>
-            <a:solidFill>
-              <a:srgbClr val="DCE0E6"/>
-            </a:solidFill>
+            <a:noFill/>
           </a:ln>
         </p:spPr>
         <p:style>
@@ -5218,14 +6187,14 @@
       </p:sp>
       <p:sp>
         <p:nvSpPr>
-          <p:cNvPr id="4" name="TextBox 3"/>
+          <p:cNvPr id="3" name="TextBox 2"/>
           <p:cNvSpPr txBox="1"/>
           <p:nvPr/>
         </p:nvSpPr>
         <p:spPr>
           <a:xfrm>
-            <a:off x="822960" y="1645920"/>
-            <a:ext cx="3200400" cy="4297680"/>
+            <a:off x="731520" y="365760"/>
+            <a:ext cx="9144000" cy="868680"/>
           </a:xfrm>
           <a:prstGeom prst="rect">
             <a:avLst/>
@@ -5233,63 +6202,131 @@
           <a:noFill/>
         </p:spPr>
         <p:txBody>
-          <a:bodyPr wrap="square">
+          <a:bodyPr wrap="square" lIns="0" tIns="0" rIns="0" bIns="0">
             <a:spAutoFit/>
           </a:bodyPr>
           <a:lstStyle/>
           <a:p>
             <a:pPr>
-              <a:defRPr sz="1400" b="1">
-                <a:solidFill>
-                  <a:srgbClr val="0F2043"/>
-                </a:solidFill>
-              </a:defRPr>
-            </a:pPr>
-            <a:r>
-              <a:t>1. Preprocessing Leak</a:t>
-            </a:r>
-          </a:p>
-          <a:p>
-            <a:pPr>
-              <a:spcBef>
-                <a:spcPts val="1000"/>
-              </a:spcBef>
-              <a:defRPr sz="1100"/>
-            </a:pPr>
-            <a:r>
-              <a:t>• Scaling/imputing before split leaks test distribution into training.</a:t>
-            </a:r>
-            <a:br/>
-            <a:r>
-              <a:t>• Deflates test RMSE by 212 cases (87,144 vs honest 87,356).</a:t>
-            </a:r>
-            <a:br/>
-            <a:r>
-              <a:t>• Prevention: Strict Pipeline and ColumnTransformer encapsulation.</a:t>
-            </a:r>
-          </a:p>
-        </p:txBody>
-      </p:sp>
-      <p:sp>
-        <p:nvSpPr>
-          <p:cNvPr id="5" name="Rounded Rectangle 4"/>
+              <a:defRPr sz="1000" b="1">
+                <a:solidFill>
+                  <a:srgbClr val="A83F43"/>
+                </a:solidFill>
+                <a:latin typeface="Candara"/>
+              </a:defRPr>
+            </a:pPr>
+            <a:r>
+              <a:t>THEME B PIPELINE ENGINEERING</a:t>
+            </a:r>
+          </a:p>
+          <a:p>
+            <a:pPr>
+              <a:defRPr sz="2300" b="1">
+                <a:solidFill>
+                  <a:srgbClr val="5E1214"/>
+                </a:solidFill>
+                <a:latin typeface="Garamond"/>
+              </a:defRPr>
+            </a:pPr>
+            <a:r>
+              <a:t>Pipeline Discipline &amp; The Leakage Audit</a:t>
+            </a:r>
+          </a:p>
+        </p:txBody>
+      </p:sp>
+      <p:pic>
+        <p:nvPicPr>
+          <p:cNvPr id="4" name="Picture 3" descr="ashesi_logo.png"/>
+          <p:cNvPicPr>
+            <a:picLocks noChangeAspect="1"/>
+          </p:cNvPicPr>
+          <p:nvPr/>
+        </p:nvPicPr>
+        <p:blipFill>
+          <a:blip r:embed="rId2"/>
+          <a:stretch>
+            <a:fillRect/>
+          </a:stretch>
+        </p:blipFill>
+        <p:spPr>
+          <a:xfrm>
+            <a:off x="10789920" y="320040"/>
+            <a:ext cx="886539" cy="685800"/>
+          </a:xfrm>
+          <a:prstGeom prst="rect">
+            <a:avLst/>
+          </a:prstGeom>
+        </p:spPr>
+      </p:pic>
+      <p:sp>
+        <p:nvSpPr>
+          <p:cNvPr id="5" name="TextBox 4"/>
+          <p:cNvSpPr txBox="1"/>
+          <p:nvPr/>
+        </p:nvSpPr>
+        <p:spPr>
+          <a:xfrm>
+            <a:off x="731520" y="6446520"/>
+            <a:ext cx="10728655" cy="274320"/>
+          </a:xfrm>
+          <a:prstGeom prst="rect">
+            <a:avLst/>
+          </a:prstGeom>
+          <a:noFill/>
+        </p:spPr>
+        <p:txBody>
+          <a:bodyPr wrap="none" lIns="0" tIns="0" rIns="0" bIns="0">
+            <a:spAutoFit/>
+          </a:bodyPr>
+          <a:lstStyle/>
+          <a:p>
+            <a:pPr>
+              <a:defRPr sz="900">
+                <a:solidFill>
+                  <a:srgbClr val="5A626A"/>
+                </a:solidFill>
+                <a:latin typeface="Candara"/>
+              </a:defRPr>
+            </a:pPr>
+            <a:r>
+              <a:t>Ashesi University · ICS553 Machine Learning Essentials · Group 3 · Prosit 1 Advisory Brief</a:t>
+            </a:r>
+          </a:p>
+          <a:p>
+            <a:pPr algn="r">
+              <a:defRPr sz="900">
+                <a:solidFill>
+                  <a:srgbClr val="5A626A"/>
+                </a:solidFill>
+                <a:latin typeface="Candara"/>
+              </a:defRPr>
+            </a:pPr>
+            <a:r>
+              <a:t>6</a:t>
+            </a:r>
+          </a:p>
+        </p:txBody>
+      </p:sp>
+      <p:sp>
+        <p:nvSpPr>
+          <p:cNvPr id="6" name="Rounded Rectangle 5"/>
           <p:cNvSpPr/>
           <p:nvPr/>
         </p:nvSpPr>
         <p:spPr>
           <a:xfrm>
-            <a:off x="4389120" y="1463040"/>
+            <a:off x="731520" y="1463040"/>
             <a:ext cx="3383280" cy="4663440"/>
           </a:xfrm>
           <a:prstGeom prst="roundRect">
             <a:avLst/>
           </a:prstGeom>
           <a:solidFill>
-            <a:srgbClr val="F5F7FA"/>
+            <a:srgbClr val="F8F9FA"/>
           </a:solidFill>
           <a:ln>
             <a:solidFill>
-              <a:srgbClr val="DCE0E6"/>
+              <a:srgbClr val="E2E4E8"/>
             </a:solidFill>
           </a:ln>
         </p:spPr>
@@ -5317,14 +6354,14 @@
       </p:sp>
       <p:sp>
         <p:nvSpPr>
-          <p:cNvPr id="6" name="TextBox 5"/>
+          <p:cNvPr id="7" name="TextBox 6"/>
           <p:cNvSpPr txBox="1"/>
           <p:nvPr/>
         </p:nvSpPr>
         <p:spPr>
           <a:xfrm>
-            <a:off x="4480560" y="1645920"/>
-            <a:ext cx="3200400" cy="4297680"/>
+            <a:off x="868680" y="1645920"/>
+            <a:ext cx="3108960" cy="4297680"/>
           </a:xfrm>
           <a:prstGeom prst="rect">
             <a:avLst/>
@@ -5338,14 +6375,15 @@
           <a:lstStyle/>
           <a:p>
             <a:pPr>
-              <a:defRPr sz="1400" b="1">
-                <a:solidFill>
-                  <a:srgbClr val="C0392B"/>
-                </a:solidFill>
-              </a:defRPr>
-            </a:pPr>
-            <a:r>
-              <a:t>2. Target Encoding Catastrophe</a:t>
+              <a:defRPr sz="1500" b="1">
+                <a:solidFill>
+                  <a:srgbClr val="5E1214"/>
+                </a:solidFill>
+                <a:latin typeface="Garamond"/>
+              </a:defRPr>
+            </a:pPr>
+            <a:r>
+              <a:t>1. Preprocessing Leak</a:t>
             </a:r>
           </a:p>
           <a:p>
@@ -5353,42 +6391,46 @@
               <a:spcBef>
                 <a:spcPts val="1000"/>
               </a:spcBef>
-              <a:defRPr sz="1100"/>
-            </a:pPr>
-            <a:r>
-              <a:t>• Encoding district by target mean without out-of-fold regularization.</a:t>
+              <a:defRPr sz="1100">
+                <a:latin typeface="Candara"/>
+              </a:defRPr>
+            </a:pPr>
+            <a:r>
+              <a:t>• Scaling/imputing before split leaks test distribution into training.</a:t>
             </a:r>
             <a:br/>
-            <a:r>
-              <a:t>• Model memorizes training targets, faking R² = 1.0000 (honest 0.4905).</a:t>
-            </a:r>
             <a:br/>
             <a:r>
-              <a:t>• Prevention: Target encoding rejected entirely.</a:t>
-            </a:r>
-          </a:p>
-        </p:txBody>
-      </p:sp>
-      <p:sp>
-        <p:nvSpPr>
-          <p:cNvPr id="7" name="Rounded Rectangle 6"/>
+              <a:t>• Deflates test RMSE by 212 cases (87,144 vs honest 87,356).</a:t>
+            </a:r>
+            <a:br/>
+            <a:br/>
+            <a:r>
+              <a:t>• Prevention: Strict Pipeline and ColumnTransformer encapsulation.</a:t>
+            </a:r>
+          </a:p>
+        </p:txBody>
+      </p:sp>
+      <p:sp>
+        <p:nvSpPr>
+          <p:cNvPr id="8" name="Rounded Rectangle 7"/>
           <p:cNvSpPr/>
           <p:nvPr/>
         </p:nvSpPr>
         <p:spPr>
           <a:xfrm>
-            <a:off x="8046720" y="1463040"/>
+            <a:off x="4389120" y="1463040"/>
             <a:ext cx="3383280" cy="4663440"/>
           </a:xfrm>
           <a:prstGeom prst="roundRect">
             <a:avLst/>
           </a:prstGeom>
           <a:solidFill>
-            <a:srgbClr val="F5F7FA"/>
+            <a:srgbClr val="F8F9FA"/>
           </a:solidFill>
           <a:ln>
             <a:solidFill>
-              <a:srgbClr val="DCE0E6"/>
+              <a:srgbClr val="E2E4E8"/>
             </a:solidFill>
           </a:ln>
         </p:spPr>
@@ -5416,14 +6458,14 @@
       </p:sp>
       <p:sp>
         <p:nvSpPr>
-          <p:cNvPr id="8" name="TextBox 7"/>
+          <p:cNvPr id="9" name="TextBox 8"/>
           <p:cNvSpPr txBox="1"/>
           <p:nvPr/>
         </p:nvSpPr>
         <p:spPr>
           <a:xfrm>
-            <a:off x="8138160" y="1645920"/>
-            <a:ext cx="3200400" cy="4297680"/>
+            <a:off x="4526280" y="1645920"/>
+            <a:ext cx="3108960" cy="4297680"/>
           </a:xfrm>
           <a:prstGeom prst="rect">
             <a:avLst/>
@@ -5437,14 +6479,15 @@
           <a:lstStyle/>
           <a:p>
             <a:pPr>
-              <a:defRPr sz="1400" b="1">
-                <a:solidFill>
-                  <a:srgbClr val="0F2043"/>
-                </a:solidFill>
-              </a:defRPr>
-            </a:pPr>
-            <a:r>
-              <a:t>3. Spatial Autocorrelation</a:t>
+              <a:defRPr sz="1500" b="1">
+                <a:solidFill>
+                  <a:srgbClr val="B33939"/>
+                </a:solidFill>
+                <a:latin typeface="Garamond"/>
+              </a:defRPr>
+            </a:pPr>
+            <a:r>
+              <a:t>2. Target Encoding Catastrophe</a:t>
             </a:r>
           </a:p>
           <a:p>
@@ -5452,15 +6495,123 @@
               <a:spcBef>
                 <a:spcPts val="1000"/>
               </a:spcBef>
-              <a:defRPr sz="1100"/>
+              <a:defRPr sz="1100">
+                <a:latin typeface="Candara"/>
+              </a:defRPr>
+            </a:pPr>
+            <a:r>
+              <a:t>• Encoding district by target mean without out-of-fold regularization.</a:t>
+            </a:r>
+            <a:br/>
+            <a:br/>
+            <a:r>
+              <a:t>• Model memorizes training targets, faking R² = 1.0000 (honest 0.4905).</a:t>
+            </a:r>
+            <a:br/>
+            <a:br/>
+            <a:r>
+              <a:t>• Prevention: Target encoding rejected entirely.</a:t>
+            </a:r>
+          </a:p>
+        </p:txBody>
+      </p:sp>
+      <p:sp>
+        <p:nvSpPr>
+          <p:cNvPr id="10" name="Rounded Rectangle 9"/>
+          <p:cNvSpPr/>
+          <p:nvPr/>
+        </p:nvSpPr>
+        <p:spPr>
+          <a:xfrm>
+            <a:off x="8046720" y="1463040"/>
+            <a:ext cx="3383280" cy="4663440"/>
+          </a:xfrm>
+          <a:prstGeom prst="roundRect">
+            <a:avLst/>
+          </a:prstGeom>
+          <a:solidFill>
+            <a:srgbClr val="F8F9FA"/>
+          </a:solidFill>
+          <a:ln>
+            <a:solidFill>
+              <a:srgbClr val="E2E4E8"/>
+            </a:solidFill>
+          </a:ln>
+        </p:spPr>
+        <p:style>
+          <a:lnRef idx="1">
+            <a:schemeClr val="accent1"/>
+          </a:lnRef>
+          <a:fillRef idx="3">
+            <a:schemeClr val="accent1"/>
+          </a:fillRef>
+          <a:effectRef idx="2">
+            <a:schemeClr val="accent1"/>
+          </a:effectRef>
+          <a:fontRef idx="minor">
+            <a:schemeClr val="lt1"/>
+          </a:fontRef>
+        </p:style>
+        <p:txBody>
+          <a:bodyPr rtlCol="0" anchor="ctr"/>
+          <a:lstStyle/>
+          <a:p>
+            <a:pPr algn="ctr"/>
+          </a:p>
+        </p:txBody>
+      </p:sp>
+      <p:sp>
+        <p:nvSpPr>
+          <p:cNvPr id="11" name="TextBox 10"/>
+          <p:cNvSpPr txBox="1"/>
+          <p:nvPr/>
+        </p:nvSpPr>
+        <p:spPr>
+          <a:xfrm>
+            <a:off x="8183879" y="1645920"/>
+            <a:ext cx="3108960" cy="4297680"/>
+          </a:xfrm>
+          <a:prstGeom prst="rect">
+            <a:avLst/>
+          </a:prstGeom>
+          <a:noFill/>
+        </p:spPr>
+        <p:txBody>
+          <a:bodyPr wrap="square">
+            <a:spAutoFit/>
+          </a:bodyPr>
+          <a:lstStyle/>
+          <a:p>
+            <a:pPr>
+              <a:defRPr sz="1500" b="1">
+                <a:solidFill>
+                  <a:srgbClr val="5E1214"/>
+                </a:solidFill>
+                <a:latin typeface="Garamond"/>
+              </a:defRPr>
+            </a:pPr>
+            <a:r>
+              <a:t>3. Spatial Autocorrelation</a:t>
+            </a:r>
+          </a:p>
+          <a:p>
+            <a:pPr>
+              <a:spcBef>
+                <a:spcPts val="1000"/>
+              </a:spcBef>
+              <a:defRPr sz="1100">
+                <a:latin typeface="Candara"/>
+              </a:defRPr>
             </a:pPr>
             <a:r>
               <a:t>• Random 80/20 train/test splits place neighboring districts on both sides.</a:t>
             </a:r>
             <a:br/>
+            <a:br/>
             <a:r>
               <a:t>• Model 'peeks' at geographic twin; test error drops by 45.5% (47,646 vs 87,356).</a:t>
             </a:r>
+            <a:br/>
             <a:br/>
             <a:r>
               <a:t>• Prevention: Region-stratified holdout split.</a:t>
@@ -5488,175 +6639,24 @@
       <p:grpSpPr/>
       <p:sp>
         <p:nvSpPr>
-          <p:cNvPr id="2" name="TextBox 1"/>
-          <p:cNvSpPr txBox="1"/>
-          <p:nvPr/>
-        </p:nvSpPr>
-        <p:spPr>
-          <a:xfrm>
-            <a:off x="731520" y="365760"/>
-            <a:ext cx="10728655" cy="822960"/>
+          <p:cNvPr id="2" name="Rectangle 1"/>
+          <p:cNvSpPr/>
+          <p:nvPr/>
+        </p:nvSpPr>
+        <p:spPr>
+          <a:xfrm>
+            <a:off x="0" y="0"/>
+            <a:ext cx="12191695" cy="73152"/>
           </a:xfrm>
           <a:prstGeom prst="rect">
             <a:avLst/>
           </a:prstGeom>
-          <a:noFill/>
-        </p:spPr>
-        <p:txBody>
-          <a:bodyPr wrap="square" lIns="0" tIns="0" rIns="0" bIns="0">
-            <a:spAutoFit/>
-          </a:bodyPr>
-          <a:lstStyle/>
-          <a:p>
-            <a:pPr>
-              <a:defRPr sz="1100" b="1">
-                <a:solidFill>
-                  <a:srgbClr val="009688"/>
-                </a:solidFill>
-              </a:defRPr>
-            </a:pPr>
-            <a:r>
-              <a:t>THEME C RESOURCE OPTIMIZATION</a:t>
-            </a:r>
-          </a:p>
-          <a:p>
-            <a:pPr>
-              <a:defRPr sz="2200" b="1">
-                <a:solidFill>
-                  <a:srgbClr val="0F2043"/>
-                </a:solidFill>
-              </a:defRPr>
-            </a:pPr>
-            <a:r>
-              <a:t>The Equitable Need-Weighted Allocation Policy</a:t>
-            </a:r>
-          </a:p>
-        </p:txBody>
-      </p:sp>
-      <p:sp>
-        <p:nvSpPr>
-          <p:cNvPr id="3" name="TextBox 2"/>
-          <p:cNvSpPr txBox="1"/>
-          <p:nvPr/>
-        </p:nvSpPr>
-        <p:spPr>
-          <a:xfrm>
-            <a:off x="731520" y="1371600"/>
-            <a:ext cx="10728655" cy="4937760"/>
-          </a:xfrm>
-          <a:prstGeom prst="rect">
-            <a:avLst/>
-          </a:prstGeom>
-          <a:noFill/>
-        </p:spPr>
-        <p:txBody>
-          <a:bodyPr wrap="square">
-            <a:spAutoFit/>
-          </a:bodyPr>
-          <a:lstStyle/>
-          <a:p>
-            <a:pPr>
-              <a:defRPr sz="1800" b="1">
-                <a:solidFill>
-                  <a:srgbClr val="0F2043"/>
-                </a:solidFill>
-              </a:defRPr>
-            </a:pPr>
-            <a:r>
-              <a:t>Three Pillars of the Proposed Allocation Model</a:t>
-            </a:r>
-          </a:p>
-          <a:p>
-            <a:pPr>
-              <a:spcBef>
-                <a:spcPts val="1400"/>
-              </a:spcBef>
-            </a:pPr>
-            <a:r>
-              <a:rPr b="1" sz="1400">
-                <a:solidFill>
-                  <a:srgbClr val="009688"/>
-                </a:solidFill>
-              </a:rPr>
-              <a:t>1. Upper-Bound Epidemic Risk (mu_upper):
-</a:t>
-            </a:r>
-            <a:r>
-              <a:rPr sz="1200">
-                <a:solidFill>
-                  <a:srgbClr val="212121"/>
-                </a:solidFill>
-              </a:rPr>
-              <a:t> We extract the upper bound of the 95% prediction interval from the Negative Binomial model. This implements an asymmetric minimax hedge, ensuring districts are protected against worst-case epidemic spikes.</a:t>
-            </a:r>
-          </a:p>
-          <a:p>
-            <a:pPr>
-              <a:spcBef>
-                <a:spcPts val="1400"/>
-              </a:spcBef>
-            </a:pPr>
-            <a:r>
-              <a:rPr b="1" sz="1400">
-                <a:solidFill>
-                  <a:srgbClr val="009688"/>
-                </a:solidFill>
-              </a:rPr>
-              <a:t>2. The Unmet Coverage Gap (1 - Coverage):
-</a:t>
-            </a:r>
-            <a:r>
-              <a:rPr sz="1200">
-                <a:solidFill>
-                  <a:srgbClr val="212121"/>
-                </a:solidFill>
-              </a:rPr>
-              <a:t> Bed nets produce herd immunity. Districts with ~80% coverage experience diminishing marginal returns. Weighting by (1 - coverage/100) directs nets where baseline household ownership is lowest.</a:t>
-            </a:r>
-          </a:p>
-          <a:p>
-            <a:pPr>
-              <a:spcBef>
-                <a:spcPts val="1400"/>
-              </a:spcBef>
-            </a:pPr>
-            <a:r>
-              <a:rPr b="1" sz="1400">
-                <a:solidFill>
-                  <a:srgbClr val="009688"/>
-                </a:solidFill>
-              </a:rPr>
-              <a:t>3. Hamilton Integer Apportionment:
-</a:t>
-            </a:r>
-            <a:r>
-              <a:rPr sz="1200">
-                <a:solidFill>
-                  <a:srgbClr val="212121"/>
-                </a:solidFill>
-              </a:rPr>
-              <a:t> Guarantees that exactly 50,000 integer nets are allocated (no fractional nets, no budget drops) by awarding floor quotas and distributing remainders to largest fractional deficits.</a:t>
-            </a:r>
-          </a:p>
-        </p:txBody>
-      </p:sp>
-      <p:sp>
-        <p:nvSpPr>
-          <p:cNvPr id="4" name="Rectangle 3"/>
-          <p:cNvSpPr/>
-          <p:nvPr/>
-        </p:nvSpPr>
-        <p:spPr>
-          <a:xfrm>
-            <a:off x="731520" y="5120640"/>
-            <a:ext cx="10728655" cy="1005840"/>
-          </a:xfrm>
-          <a:prstGeom prst="rect">
-            <a:avLst/>
-          </a:prstGeom>
           <a:solidFill>
-            <a:srgbClr val="0F2043"/>
+            <a:srgbClr val="A83F43"/>
           </a:solidFill>
+          <a:ln>
+            <a:noFill/>
+          </a:ln>
         </p:spPr>
         <p:style>
           <a:lnRef idx="1">
@@ -5673,14 +6673,291 @@
           </a:fontRef>
         </p:style>
         <p:txBody>
+          <a:bodyPr rtlCol="0" anchor="ctr"/>
+          <a:lstStyle/>
+          <a:p>
+            <a:pPr algn="ctr"/>
+          </a:p>
+        </p:txBody>
+      </p:sp>
+      <p:sp>
+        <p:nvSpPr>
+          <p:cNvPr id="3" name="TextBox 2"/>
+          <p:cNvSpPr txBox="1"/>
+          <p:nvPr/>
+        </p:nvSpPr>
+        <p:spPr>
+          <a:xfrm>
+            <a:off x="731520" y="365760"/>
+            <a:ext cx="9144000" cy="868680"/>
+          </a:xfrm>
+          <a:prstGeom prst="rect">
+            <a:avLst/>
+          </a:prstGeom>
+          <a:noFill/>
+        </p:spPr>
+        <p:txBody>
+          <a:bodyPr wrap="square" lIns="0" tIns="0" rIns="0" bIns="0">
+            <a:spAutoFit/>
+          </a:bodyPr>
+          <a:lstStyle/>
+          <a:p>
+            <a:pPr>
+              <a:defRPr sz="1000" b="1">
+                <a:solidFill>
+                  <a:srgbClr val="A83F43"/>
+                </a:solidFill>
+                <a:latin typeface="Candara"/>
+              </a:defRPr>
+            </a:pPr>
+            <a:r>
+              <a:t>THEME C RESOURCE OPTIMIZATION</a:t>
+            </a:r>
+          </a:p>
+          <a:p>
+            <a:pPr>
+              <a:defRPr sz="2300" b="1">
+                <a:solidFill>
+                  <a:srgbClr val="5E1214"/>
+                </a:solidFill>
+                <a:latin typeface="Garamond"/>
+              </a:defRPr>
+            </a:pPr>
+            <a:r>
+              <a:t>The Equitable Need-Weighted Allocation Policy</a:t>
+            </a:r>
+          </a:p>
+        </p:txBody>
+      </p:sp>
+      <p:pic>
+        <p:nvPicPr>
+          <p:cNvPr id="4" name="Picture 3" descr="ashesi_logo.png"/>
+          <p:cNvPicPr>
+            <a:picLocks noChangeAspect="1"/>
+          </p:cNvPicPr>
+          <p:nvPr/>
+        </p:nvPicPr>
+        <p:blipFill>
+          <a:blip r:embed="rId2"/>
+          <a:stretch>
+            <a:fillRect/>
+          </a:stretch>
+        </p:blipFill>
+        <p:spPr>
+          <a:xfrm>
+            <a:off x="10789920" y="320040"/>
+            <a:ext cx="886539" cy="685800"/>
+          </a:xfrm>
+          <a:prstGeom prst="rect">
+            <a:avLst/>
+          </a:prstGeom>
+        </p:spPr>
+      </p:pic>
+      <p:sp>
+        <p:nvSpPr>
+          <p:cNvPr id="5" name="TextBox 4"/>
+          <p:cNvSpPr txBox="1"/>
+          <p:nvPr/>
+        </p:nvSpPr>
+        <p:spPr>
+          <a:xfrm>
+            <a:off x="731520" y="6446520"/>
+            <a:ext cx="10728655" cy="274320"/>
+          </a:xfrm>
+          <a:prstGeom prst="rect">
+            <a:avLst/>
+          </a:prstGeom>
+          <a:noFill/>
+        </p:spPr>
+        <p:txBody>
+          <a:bodyPr wrap="none" lIns="0" tIns="0" rIns="0" bIns="0">
+            <a:spAutoFit/>
+          </a:bodyPr>
+          <a:lstStyle/>
+          <a:p>
+            <a:pPr>
+              <a:defRPr sz="900">
+                <a:solidFill>
+                  <a:srgbClr val="5A626A"/>
+                </a:solidFill>
+                <a:latin typeface="Candara"/>
+              </a:defRPr>
+            </a:pPr>
+            <a:r>
+              <a:t>Ashesi University · ICS553 Machine Learning Essentials · Group 3 · Prosit 1 Advisory Brief</a:t>
+            </a:r>
+          </a:p>
+          <a:p>
+            <a:pPr algn="r">
+              <a:defRPr sz="900">
+                <a:solidFill>
+                  <a:srgbClr val="5A626A"/>
+                </a:solidFill>
+                <a:latin typeface="Candara"/>
+              </a:defRPr>
+            </a:pPr>
+            <a:r>
+              <a:t>7</a:t>
+            </a:r>
+          </a:p>
+        </p:txBody>
+      </p:sp>
+      <p:sp>
+        <p:nvSpPr>
+          <p:cNvPr id="6" name="TextBox 5"/>
+          <p:cNvSpPr txBox="1"/>
+          <p:nvPr/>
+        </p:nvSpPr>
+        <p:spPr>
+          <a:xfrm>
+            <a:off x="731520" y="1371600"/>
+            <a:ext cx="10728655" cy="4937760"/>
+          </a:xfrm>
+          <a:prstGeom prst="rect">
+            <a:avLst/>
+          </a:prstGeom>
+          <a:noFill/>
+        </p:spPr>
+        <p:txBody>
+          <a:bodyPr wrap="square">
+            <a:spAutoFit/>
+          </a:bodyPr>
+          <a:lstStyle/>
+          <a:p>
+            <a:pPr>
+              <a:defRPr sz="1800" b="1">
+                <a:solidFill>
+                  <a:srgbClr val="5E1214"/>
+                </a:solidFill>
+                <a:latin typeface="Garamond"/>
+              </a:defRPr>
+            </a:pPr>
+            <a:r>
+              <a:t>Three Pillars of the Proposed Allocation Model</a:t>
+            </a:r>
+          </a:p>
+          <a:p>
+            <a:pPr>
+              <a:spcBef>
+                <a:spcPts val="1200"/>
+              </a:spcBef>
+            </a:pPr>
+            <a:r>
+              <a:rPr b="1" sz="1300">
+                <a:solidFill>
+                  <a:srgbClr val="A83F43"/>
+                </a:solidFill>
+                <a:latin typeface="Candara"/>
+              </a:rPr>
+              <a:t>1. Upper-Bound Epidemic Risk (mu_upper):
+</a:t>
+            </a:r>
+            <a:r>
+              <a:rPr sz="1100">
+                <a:solidFill>
+                  <a:srgbClr val="1E2022"/>
+                </a:solidFill>
+                <a:latin typeface="Candara"/>
+              </a:rPr>
+              <a:t> We extract the upper bound of the 95% prediction interval from the Negative Binomial model. This implements an asymmetric minimax hedge, ensuring districts are protected against worst-case epidemic spikes.</a:t>
+            </a:r>
+          </a:p>
+          <a:p>
+            <a:pPr>
+              <a:spcBef>
+                <a:spcPts val="1200"/>
+              </a:spcBef>
+            </a:pPr>
+            <a:r>
+              <a:rPr b="1" sz="1300">
+                <a:solidFill>
+                  <a:srgbClr val="A83F43"/>
+                </a:solidFill>
+                <a:latin typeface="Candara"/>
+              </a:rPr>
+              <a:t>2. The Unmet Coverage Gap (1 - Coverage):
+</a:t>
+            </a:r>
+            <a:r>
+              <a:rPr sz="1100">
+                <a:solidFill>
+                  <a:srgbClr val="1E2022"/>
+                </a:solidFill>
+                <a:latin typeface="Candara"/>
+              </a:rPr>
+              <a:t> Bed nets produce herd immunity. Districts with ~80% coverage experience diminishing marginal returns. Weighting by (1 - coverage/100) directs nets where baseline household ownership is lowest.</a:t>
+            </a:r>
+          </a:p>
+          <a:p>
+            <a:pPr>
+              <a:spcBef>
+                <a:spcPts val="1200"/>
+              </a:spcBef>
+            </a:pPr>
+            <a:r>
+              <a:rPr b="1" sz="1300">
+                <a:solidFill>
+                  <a:srgbClr val="A83F43"/>
+                </a:solidFill>
+                <a:latin typeface="Candara"/>
+              </a:rPr>
+              <a:t>3. Hamilton Integer Apportionment:
+</a:t>
+            </a:r>
+            <a:r>
+              <a:rPr sz="1100">
+                <a:solidFill>
+                  <a:srgbClr val="1E2022"/>
+                </a:solidFill>
+                <a:latin typeface="Candara"/>
+              </a:rPr>
+              <a:t> Guarantees that exactly 50,000 integer nets are allocated (no fractional nets, no budget drops) by awarding floor quotas and distributing remainders to largest fractional deficits.</a:t>
+            </a:r>
+          </a:p>
+        </p:txBody>
+      </p:sp>
+      <p:sp>
+        <p:nvSpPr>
+          <p:cNvPr id="7" name="Rectangle 6"/>
+          <p:cNvSpPr/>
+          <p:nvPr/>
+        </p:nvSpPr>
+        <p:spPr>
+          <a:xfrm>
+            <a:off x="731520" y="5120640"/>
+            <a:ext cx="10728655" cy="1005840"/>
+          </a:xfrm>
+          <a:prstGeom prst="rect">
+            <a:avLst/>
+          </a:prstGeom>
+          <a:solidFill>
+            <a:srgbClr val="5E1214"/>
+          </a:solidFill>
+        </p:spPr>
+        <p:style>
+          <a:lnRef idx="1">
+            <a:schemeClr val="accent1"/>
+          </a:lnRef>
+          <a:fillRef idx="3">
+            <a:schemeClr val="accent1"/>
+          </a:fillRef>
+          <a:effectRef idx="2">
+            <a:schemeClr val="accent1"/>
+          </a:effectRef>
+          <a:fontRef idx="minor">
+            <a:schemeClr val="lt1"/>
+          </a:fontRef>
+        </p:style>
+        <p:txBody>
           <a:bodyPr rtlCol="0" anchor="ctr" wrap="square"/>
           <a:lstStyle/>
           <a:p>
             <a:pPr algn="ctr">
               <a:defRPr sz="1500" b="1">
                 <a:solidFill>
-                  <a:srgbClr val="FFFFFF"/>
-                </a:solidFill>
+                  <a:srgbClr val="C59B27"/>
+                </a:solidFill>
+                <a:latin typeface="Candara"/>
               </a:defRPr>
             </a:pPr>
             <a:r>
@@ -5709,96 +6986,23 @@
       <p:grpSpPr/>
       <p:sp>
         <p:nvSpPr>
-          <p:cNvPr id="2" name="TextBox 1"/>
-          <p:cNvSpPr txBox="1"/>
-          <p:nvPr/>
-        </p:nvSpPr>
-        <p:spPr>
-          <a:xfrm>
-            <a:off x="731520" y="365760"/>
-            <a:ext cx="10728655" cy="822960"/>
+          <p:cNvPr id="2" name="Rectangle 1"/>
+          <p:cNvSpPr/>
+          <p:nvPr/>
+        </p:nvSpPr>
+        <p:spPr>
+          <a:xfrm>
+            <a:off x="0" y="0"/>
+            <a:ext cx="12191695" cy="73152"/>
           </a:xfrm>
           <a:prstGeom prst="rect">
             <a:avLst/>
           </a:prstGeom>
-          <a:noFill/>
-        </p:spPr>
-        <p:txBody>
-          <a:bodyPr wrap="square" lIns="0" tIns="0" rIns="0" bIns="0">
-            <a:spAutoFit/>
-          </a:bodyPr>
-          <a:lstStyle/>
-          <a:p>
-            <a:pPr>
-              <a:defRPr sz="1100" b="1">
-                <a:solidFill>
-                  <a:srgbClr val="009688"/>
-                </a:solidFill>
-              </a:defRPr>
-            </a:pPr>
-            <a:r>
-              <a:t>THEME C GEOSPATIAL ALLOCATION</a:t>
-            </a:r>
-          </a:p>
-          <a:p>
-            <a:pPr>
-              <a:defRPr sz="2200" b="1">
-                <a:solidFill>
-                  <a:srgbClr val="0F2043"/>
-                </a:solidFill>
-              </a:defRPr>
-            </a:pPr>
-            <a:r>
-              <a:t>Map Highlight: 50,000 Net Distribution Across Northern Ghana</a:t>
-            </a:r>
-          </a:p>
-        </p:txBody>
-      </p:sp>
-      <p:pic>
-        <p:nvPicPr>
-          <p:cNvPr id="3" name="Picture 2" descr="c2_allocation_map.png"/>
-          <p:cNvPicPr>
-            <a:picLocks noChangeAspect="1"/>
-          </p:cNvPicPr>
-          <p:nvPr/>
-        </p:nvPicPr>
-        <p:blipFill>
-          <a:blip r:embed="rId2"/>
-          <a:stretch>
-            <a:fillRect/>
-          </a:stretch>
-        </p:blipFill>
-        <p:spPr>
-          <a:xfrm>
-            <a:off x="731520" y="1371600"/>
-            <a:ext cx="4572000" cy="7289800"/>
-          </a:xfrm>
-          <a:prstGeom prst="rect">
-            <a:avLst/>
-          </a:prstGeom>
-        </p:spPr>
-      </p:pic>
-      <p:sp>
-        <p:nvSpPr>
-          <p:cNvPr id="4" name="Rounded Rectangle 3"/>
-          <p:cNvSpPr/>
-          <p:nvPr/>
-        </p:nvSpPr>
-        <p:spPr>
-          <a:xfrm>
-            <a:off x="5669280" y="1371600"/>
-            <a:ext cx="5760720" cy="4846320"/>
-          </a:xfrm>
-          <a:prstGeom prst="roundRect">
-            <a:avLst/>
-          </a:prstGeom>
           <a:solidFill>
-            <a:srgbClr val="F5F7FA"/>
+            <a:srgbClr val="A83F43"/>
           </a:solidFill>
           <a:ln>
-            <a:solidFill>
-              <a:srgbClr val="DCE0E6"/>
-            </a:solidFill>
+            <a:noFill/>
           </a:ln>
         </p:spPr>
         <p:style>
@@ -5825,7 +7029,198 @@
       </p:sp>
       <p:sp>
         <p:nvSpPr>
+          <p:cNvPr id="3" name="TextBox 2"/>
+          <p:cNvSpPr txBox="1"/>
+          <p:nvPr/>
+        </p:nvSpPr>
+        <p:spPr>
+          <a:xfrm>
+            <a:off x="731520" y="365760"/>
+            <a:ext cx="9144000" cy="868680"/>
+          </a:xfrm>
+          <a:prstGeom prst="rect">
+            <a:avLst/>
+          </a:prstGeom>
+          <a:noFill/>
+        </p:spPr>
+        <p:txBody>
+          <a:bodyPr wrap="square" lIns="0" tIns="0" rIns="0" bIns="0">
+            <a:spAutoFit/>
+          </a:bodyPr>
+          <a:lstStyle/>
+          <a:p>
+            <a:pPr>
+              <a:defRPr sz="1000" b="1">
+                <a:solidFill>
+                  <a:srgbClr val="A83F43"/>
+                </a:solidFill>
+                <a:latin typeface="Candara"/>
+              </a:defRPr>
+            </a:pPr>
+            <a:r>
+              <a:t>THEME C GEOSPATIAL ALLOCATION</a:t>
+            </a:r>
+          </a:p>
+          <a:p>
+            <a:pPr>
+              <a:defRPr sz="2300" b="1">
+                <a:solidFill>
+                  <a:srgbClr val="5E1214"/>
+                </a:solidFill>
+                <a:latin typeface="Garamond"/>
+              </a:defRPr>
+            </a:pPr>
+            <a:r>
+              <a:t>Map Highlight: 50,000 Net Distribution Across Northern Ghana</a:t>
+            </a:r>
+          </a:p>
+        </p:txBody>
+      </p:sp>
+      <p:pic>
+        <p:nvPicPr>
+          <p:cNvPr id="4" name="Picture 3" descr="ashesi_logo.png"/>
+          <p:cNvPicPr>
+            <a:picLocks noChangeAspect="1"/>
+          </p:cNvPicPr>
+          <p:nvPr/>
+        </p:nvPicPr>
+        <p:blipFill>
+          <a:blip r:embed="rId2"/>
+          <a:stretch>
+            <a:fillRect/>
+          </a:stretch>
+        </p:blipFill>
+        <p:spPr>
+          <a:xfrm>
+            <a:off x="10789920" y="320040"/>
+            <a:ext cx="886539" cy="685800"/>
+          </a:xfrm>
+          <a:prstGeom prst="rect">
+            <a:avLst/>
+          </a:prstGeom>
+        </p:spPr>
+      </p:pic>
+      <p:sp>
+        <p:nvSpPr>
           <p:cNvPr id="5" name="TextBox 4"/>
+          <p:cNvSpPr txBox="1"/>
+          <p:nvPr/>
+        </p:nvSpPr>
+        <p:spPr>
+          <a:xfrm>
+            <a:off x="731520" y="6446520"/>
+            <a:ext cx="10728655" cy="274320"/>
+          </a:xfrm>
+          <a:prstGeom prst="rect">
+            <a:avLst/>
+          </a:prstGeom>
+          <a:noFill/>
+        </p:spPr>
+        <p:txBody>
+          <a:bodyPr wrap="none" lIns="0" tIns="0" rIns="0" bIns="0">
+            <a:spAutoFit/>
+          </a:bodyPr>
+          <a:lstStyle/>
+          <a:p>
+            <a:pPr>
+              <a:defRPr sz="900">
+                <a:solidFill>
+                  <a:srgbClr val="5A626A"/>
+                </a:solidFill>
+                <a:latin typeface="Candara"/>
+              </a:defRPr>
+            </a:pPr>
+            <a:r>
+              <a:t>Ashesi University · ICS553 Machine Learning Essentials · Group 3 · Prosit 1 Advisory Brief</a:t>
+            </a:r>
+          </a:p>
+          <a:p>
+            <a:pPr algn="r">
+              <a:defRPr sz="900">
+                <a:solidFill>
+                  <a:srgbClr val="5A626A"/>
+                </a:solidFill>
+                <a:latin typeface="Candara"/>
+              </a:defRPr>
+            </a:pPr>
+            <a:r>
+              <a:t>8</a:t>
+            </a:r>
+          </a:p>
+        </p:txBody>
+      </p:sp>
+      <p:pic>
+        <p:nvPicPr>
+          <p:cNvPr id="6" name="Picture 5" descr="c2_allocation_map.png"/>
+          <p:cNvPicPr>
+            <a:picLocks noChangeAspect="1"/>
+          </p:cNvPicPr>
+          <p:nvPr/>
+        </p:nvPicPr>
+        <p:blipFill>
+          <a:blip r:embed="rId3"/>
+          <a:stretch>
+            <a:fillRect/>
+          </a:stretch>
+        </p:blipFill>
+        <p:spPr>
+          <a:xfrm>
+            <a:off x="731520" y="1371600"/>
+            <a:ext cx="4572000" cy="7289800"/>
+          </a:xfrm>
+          <a:prstGeom prst="rect">
+            <a:avLst/>
+          </a:prstGeom>
+        </p:spPr>
+      </p:pic>
+      <p:sp>
+        <p:nvSpPr>
+          <p:cNvPr id="7" name="Rounded Rectangle 6"/>
+          <p:cNvSpPr/>
+          <p:nvPr/>
+        </p:nvSpPr>
+        <p:spPr>
+          <a:xfrm>
+            <a:off x="5669280" y="1371600"/>
+            <a:ext cx="5760720" cy="4846320"/>
+          </a:xfrm>
+          <a:prstGeom prst="roundRect">
+            <a:avLst/>
+          </a:prstGeom>
+          <a:solidFill>
+            <a:srgbClr val="F8F9FA"/>
+          </a:solidFill>
+          <a:ln>
+            <a:solidFill>
+              <a:srgbClr val="E2E4E8"/>
+            </a:solidFill>
+          </a:ln>
+        </p:spPr>
+        <p:style>
+          <a:lnRef idx="1">
+            <a:schemeClr val="accent1"/>
+          </a:lnRef>
+          <a:fillRef idx="3">
+            <a:schemeClr val="accent1"/>
+          </a:fillRef>
+          <a:effectRef idx="2">
+            <a:schemeClr val="accent1"/>
+          </a:effectRef>
+          <a:fontRef idx="minor">
+            <a:schemeClr val="lt1"/>
+          </a:fontRef>
+        </p:style>
+        <p:txBody>
+          <a:bodyPr rtlCol="0" anchor="ctr"/>
+          <a:lstStyle/>
+          <a:p>
+            <a:pPr algn="ctr"/>
+          </a:p>
+        </p:txBody>
+      </p:sp>
+      <p:sp>
+        <p:nvSpPr>
+          <p:cNvPr id="8" name="TextBox 7"/>
           <p:cNvSpPr txBox="1"/>
           <p:nvPr/>
         </p:nvSpPr>
@@ -5846,10 +7241,11 @@
           <a:lstStyle/>
           <a:p>
             <a:pPr>
-              <a:defRPr sz="1600" b="1">
-                <a:solidFill>
-                  <a:srgbClr val="0F2043"/>
-                </a:solidFill>
+              <a:defRPr sz="1700" b="1">
+                <a:solidFill>
+                  <a:srgbClr val="5E1214"/>
+                </a:solidFill>
+                <a:latin typeface="Garamond"/>
               </a:defRPr>
             </a:pPr>
             <a:r>
@@ -5865,8 +7261,9 @@
             <a:r>
               <a:rPr b="1" sz="1300">
                 <a:solidFill>
-                  <a:srgbClr val="0F2043"/>
-                </a:solidFill>
+                  <a:srgbClr val="A83F43"/>
+                </a:solidFill>
+                <a:latin typeface="Candara"/>
               </a:rPr>
               <a:t>Northern Region Depot (Tamale):
 </a:t>
@@ -5874,8 +7271,9 @@
             <a:r>
               <a:rPr sz="1100">
                 <a:solidFill>
-                  <a:srgbClr val="212121"/>
-                </a:solidFill>
+                  <a:srgbClr val="1E2022"/>
+                </a:solidFill>
+                <a:latin typeface="Candara"/>
               </a:rPr>
               <a:t> 24,980 nets (49.96%) across 26 districts.
 Reflects lower baseline net coverage (67.7%) and largest population at risk.</a:t>
@@ -5890,8 +7288,9 @@
             <a:r>
               <a:rPr b="1" sz="1300">
                 <a:solidFill>
-                  <a:srgbClr val="0F2043"/>
-                </a:solidFill>
+                  <a:srgbClr val="A83F43"/>
+                </a:solidFill>
+                <a:latin typeface="Candara"/>
               </a:rPr>
               <a:t>Upper East Depot (Bolgatanga):
 </a:t>
@@ -5899,8 +7298,9 @@
             <a:r>
               <a:rPr sz="1100">
                 <a:solidFill>
-                  <a:srgbClr val="212121"/>
-                </a:solidFill>
+                  <a:srgbClr val="1E2022"/>
+                </a:solidFill>
+                <a:latin typeface="Candara"/>
               </a:rPr>
               <a:t> 17,547 nets (35.09%) across 13 districts.
 High historical caseload, but high baseline coverage (79.6%) dampens allocation.</a:t>
@@ -5915,8 +7315,9 @@
             <a:r>
               <a:rPr b="1" sz="1300">
                 <a:solidFill>
-                  <a:srgbClr val="0F2043"/>
-                </a:solidFill>
+                  <a:srgbClr val="A83F43"/>
+                </a:solidFill>
+                <a:latin typeface="Candara"/>
               </a:rPr>
               <a:t>Upper West Depot (Wa):
 </a:t>
@@ -5924,8 +7325,9 @@
             <a:r>
               <a:rPr sz="1100">
                 <a:solidFill>
-                  <a:srgbClr val="212121"/>
-                </a:solidFill>
+                  <a:srgbClr val="1E2022"/>
+                </a:solidFill>
+                <a:latin typeface="Candara"/>
               </a:rPr>
               <a:t> 7,473 nets (14.95%) across 11 districts.
 Corrected for hospital referral inflation; nets distributed to rural catchments.</a:t>
@@ -5953,14 +7355,57 @@
       <p:grpSpPr/>
       <p:sp>
         <p:nvSpPr>
-          <p:cNvPr id="2" name="TextBox 1"/>
+          <p:cNvPr id="2" name="Rectangle 1"/>
+          <p:cNvSpPr/>
+          <p:nvPr/>
+        </p:nvSpPr>
+        <p:spPr>
+          <a:xfrm>
+            <a:off x="0" y="0"/>
+            <a:ext cx="12191695" cy="73152"/>
+          </a:xfrm>
+          <a:prstGeom prst="rect">
+            <a:avLst/>
+          </a:prstGeom>
+          <a:solidFill>
+            <a:srgbClr val="A83F43"/>
+          </a:solidFill>
+          <a:ln>
+            <a:noFill/>
+          </a:ln>
+        </p:spPr>
+        <p:style>
+          <a:lnRef idx="1">
+            <a:schemeClr val="accent1"/>
+          </a:lnRef>
+          <a:fillRef idx="3">
+            <a:schemeClr val="accent1"/>
+          </a:fillRef>
+          <a:effectRef idx="2">
+            <a:schemeClr val="accent1"/>
+          </a:effectRef>
+          <a:fontRef idx="minor">
+            <a:schemeClr val="lt1"/>
+          </a:fontRef>
+        </p:style>
+        <p:txBody>
+          <a:bodyPr rtlCol="0" anchor="ctr"/>
+          <a:lstStyle/>
+          <a:p>
+            <a:pPr algn="ctr"/>
+          </a:p>
+        </p:txBody>
+      </p:sp>
+      <p:sp>
+        <p:nvSpPr>
+          <p:cNvPr id="3" name="TextBox 2"/>
           <p:cNvSpPr txBox="1"/>
           <p:nvPr/>
         </p:nvSpPr>
         <p:spPr>
           <a:xfrm>
             <a:off x="731520" y="365760"/>
-            <a:ext cx="10728655" cy="822960"/>
+            <a:ext cx="9144000" cy="868680"/>
           </a:xfrm>
           <a:prstGeom prst="rect">
             <a:avLst/>
@@ -5974,10 +7419,11 @@
           <a:lstStyle/>
           <a:p>
             <a:pPr>
-              <a:defRPr sz="1100" b="1">
-                <a:solidFill>
-                  <a:srgbClr val="009688"/>
-                </a:solidFill>
+              <a:defRPr sz="1000" b="1">
+                <a:solidFill>
+                  <a:srgbClr val="A83F43"/>
+                </a:solidFill>
+                <a:latin typeface="Candara"/>
               </a:defRPr>
             </a:pPr>
             <a:r>
@@ -5986,10 +7432,11 @@
           </a:p>
           <a:p>
             <a:pPr>
-              <a:defRPr sz="2200" b="1">
-                <a:solidFill>
-                  <a:srgbClr val="0F2043"/>
-                </a:solidFill>
+              <a:defRPr sz="2300" b="1">
+                <a:solidFill>
+                  <a:srgbClr val="5E1214"/>
+                </a:solidFill>
+                <a:latin typeface="Garamond"/>
               </a:defRPr>
             </a:pPr>
             <a:r>
@@ -6000,7 +7447,7 @@
       </p:sp>
       <p:pic>
         <p:nvPicPr>
-          <p:cNvPr id="3" name="Picture 2" descr="c3_policy_shift_map.png"/>
+          <p:cNvPr id="4" name="Picture 3" descr="ashesi_logo.png"/>
           <p:cNvPicPr>
             <a:picLocks noChangeAspect="1"/>
           </p:cNvPicPr>
@@ -6014,6 +7461,79 @@
         </p:blipFill>
         <p:spPr>
           <a:xfrm>
+            <a:off x="10789920" y="320040"/>
+            <a:ext cx="886539" cy="685800"/>
+          </a:xfrm>
+          <a:prstGeom prst="rect">
+            <a:avLst/>
+          </a:prstGeom>
+        </p:spPr>
+      </p:pic>
+      <p:sp>
+        <p:nvSpPr>
+          <p:cNvPr id="5" name="TextBox 4"/>
+          <p:cNvSpPr txBox="1"/>
+          <p:nvPr/>
+        </p:nvSpPr>
+        <p:spPr>
+          <a:xfrm>
+            <a:off x="731520" y="6446520"/>
+            <a:ext cx="10728655" cy="274320"/>
+          </a:xfrm>
+          <a:prstGeom prst="rect">
+            <a:avLst/>
+          </a:prstGeom>
+          <a:noFill/>
+        </p:spPr>
+        <p:txBody>
+          <a:bodyPr wrap="none" lIns="0" tIns="0" rIns="0" bIns="0">
+            <a:spAutoFit/>
+          </a:bodyPr>
+          <a:lstStyle/>
+          <a:p>
+            <a:pPr>
+              <a:defRPr sz="900">
+                <a:solidFill>
+                  <a:srgbClr val="5A626A"/>
+                </a:solidFill>
+                <a:latin typeface="Candara"/>
+              </a:defRPr>
+            </a:pPr>
+            <a:r>
+              <a:t>Ashesi University · ICS553 Machine Learning Essentials · Group 3 · Prosit 1 Advisory Brief</a:t>
+            </a:r>
+          </a:p>
+          <a:p>
+            <a:pPr algn="r">
+              <a:defRPr sz="900">
+                <a:solidFill>
+                  <a:srgbClr val="5A626A"/>
+                </a:solidFill>
+                <a:latin typeface="Candara"/>
+              </a:defRPr>
+            </a:pPr>
+            <a:r>
+              <a:t>9</a:t>
+            </a:r>
+          </a:p>
+        </p:txBody>
+      </p:sp>
+      <p:pic>
+        <p:nvPicPr>
+          <p:cNvPr id="6" name="Picture 5" descr="c3_policy_shift_map.png"/>
+          <p:cNvPicPr>
+            <a:picLocks noChangeAspect="1"/>
+          </p:cNvPicPr>
+          <p:nvPr/>
+        </p:nvPicPr>
+        <p:blipFill>
+          <a:blip r:embed="rId3"/>
+          <a:stretch>
+            <a:fillRect/>
+          </a:stretch>
+        </p:blipFill>
+        <p:spPr>
+          <a:xfrm>
             <a:off x="731520" y="1371600"/>
             <a:ext cx="5486400" cy="6288006"/>
           </a:xfrm>
@@ -6024,14 +7544,14 @@
       </p:pic>
       <p:pic>
         <p:nvPicPr>
-          <p:cNvPr id="4" name="Picture 3" descr="c1_allocation_comparison.png"/>
+          <p:cNvPr id="7" name="Picture 6" descr="c1_allocation_comparison.png"/>
           <p:cNvPicPr>
             <a:picLocks noChangeAspect="1"/>
           </p:cNvPicPr>
           <p:nvPr/>
         </p:nvPicPr>
         <p:blipFill>
-          <a:blip r:embed="rId3"/>
+          <a:blip r:embed="rId4"/>
           <a:stretch>
             <a:fillRect/>
           </a:stretch>

</xml_diff>